<commit_message>
feat(project-12): finalize 100% complete implementation, models, tests, docs, PPT, and video demonstration for PROJECT-012
</commit_message>
<xml_diff>
--- a/project_12_egg_gender_prediction/presentations/project_presentation.pptx
+++ b/project_12_egg_gender_prediction/presentations/project_presentation.pptx
@@ -13,6 +13,13 @@
     <p:sldId id="261" r:id="rId12"/>
     <p:sldId id="262" r:id="rId13"/>
     <p:sldId id="263" r:id="rId14"/>
+    <p:sldId id="264" r:id="rId15"/>
+    <p:sldId id="265" r:id="rId16"/>
+    <p:sldId id="266" r:id="rId17"/>
+    <p:sldId id="267" r:id="rId18"/>
+    <p:sldId id="268" r:id="rId19"/>
+    <p:sldId id="269" r:id="rId20"/>
+    <p:sldId id="270" r:id="rId21"/>
   </p:sldIdLst>
   <p:sldSz cx="12191695" cy="6858000" type="screen4x3"/>
   <p:notesSz cx="6858000" cy="9144000"/>
@@ -3110,7 +3117,7 @@
             <a:avLst/>
           </a:prstGeom>
           <a:solidFill>
-            <a:srgbClr val="0F172A"/>
+            <a:srgbClr val="0B132B"/>
           </a:solidFill>
           <a:ln>
             <a:noFill/>
@@ -3146,8 +3153,8 @@
         </p:nvSpPr>
         <p:spPr>
           <a:xfrm>
-            <a:off x="1097280" y="1645920"/>
-            <a:ext cx="10058400" cy="3474720"/>
+            <a:off x="914400" y="1645920"/>
+            <a:ext cx="10362895" cy="3474720"/>
           </a:xfrm>
           <a:prstGeom prst="rect">
             <a:avLst/>
@@ -3161,44 +3168,1695 @@
           <a:lstStyle/>
           <a:p>
             <a:pPr>
-              <a:defRPr sz="1400" b="1">
+              <a:defRPr sz="1300" b="1">
+                <a:solidFill>
+                  <a:srgbClr val="F59E0B"/>
+                </a:solidFill>
+              </a:defRPr>
+            </a:pPr>
+            <a:r>
+              <a:t>PROJECT 12 OF 55 • AGRICULTURAL COMPUTER VISION &amp; EMBRYOLOGY</a:t>
+            </a:r>
+          </a:p>
+          <a:p>
+            <a:pPr>
+              <a:defRPr sz="3600" b="1">
+                <a:solidFill>
+                  <a:srgbClr val="F8FAFC"/>
+                </a:solidFill>
+              </a:defRPr>
+            </a:pPr>
+            <a:r>
+              <a:t>Determination of Egg Gender Prediction</a:t>
+            </a:r>
+            <a:br/>
+            <a:r>
+              <a:t>Using Digital Image Processing &amp; Neural Networks</a:t>
+            </a:r>
+          </a:p>
+          <a:p>
+            <a:br/>
+            <a:pPr>
+              <a:defRPr sz="1500">
+                <a:solidFill>
+                  <a:srgbClr val="94A3B8"/>
+                </a:solidFill>
+              </a:defRPr>
+            </a:pPr>
+            <a:r>
+              <a:t>Non-invasive chick sex determination prior to incubation via geometric shape index morphology, contour curvature analysis, and multi-layer perceptron neural classification.</a:t>
+            </a:r>
+          </a:p>
+        </p:txBody>
+      </p:sp>
+    </p:spTree>
+  </p:cSld>
+  <p:clrMapOvr>
+    <a:masterClrMapping/>
+  </p:clrMapOvr>
+</p:sld>
+</file>
+
+<file path=ppt/slides/slide10.xml><?xml version="1.0" encoding="utf-8"?>
+<p:sld xmlns:a="http://schemas.openxmlformats.org/drawingml/2006/main" xmlns:p="http://schemas.openxmlformats.org/presentationml/2006/main" xmlns:r="http://schemas.openxmlformats.org/officeDocument/2006/relationships">
+  <p:cSld>
+    <p:spTree>
+      <p:nvGrpSpPr>
+        <p:cNvPr id="1" name=""/>
+        <p:cNvGrpSpPr/>
+        <p:nvPr/>
+      </p:nvGrpSpPr>
+      <p:grpSpPr/>
+      <p:sp>
+        <p:nvSpPr>
+          <p:cNvPr id="2" name="Rectangle 1"/>
+          <p:cNvSpPr/>
+          <p:nvPr/>
+        </p:nvSpPr>
+        <p:spPr>
+          <a:xfrm>
+            <a:off x="0" y="0"/>
+            <a:ext cx="12191695" cy="6858000"/>
+          </a:xfrm>
+          <a:prstGeom prst="rect">
+            <a:avLst/>
+          </a:prstGeom>
+          <a:solidFill>
+            <a:srgbClr val="0B132B"/>
+          </a:solidFill>
+          <a:ln>
+            <a:noFill/>
+          </a:ln>
+        </p:spPr>
+        <p:style>
+          <a:lnRef idx="1">
+            <a:schemeClr val="accent1"/>
+          </a:lnRef>
+          <a:fillRef idx="3">
+            <a:schemeClr val="accent1"/>
+          </a:fillRef>
+          <a:effectRef idx="2">
+            <a:schemeClr val="accent1"/>
+          </a:effectRef>
+          <a:fontRef idx="minor">
+            <a:schemeClr val="lt1"/>
+          </a:fontRef>
+        </p:style>
+        <p:txBody>
+          <a:bodyPr rtlCol="0" anchor="ctr"/>
+          <a:lstStyle/>
+          <a:p>
+            <a:pPr algn="ctr"/>
+          </a:p>
+        </p:txBody>
+      </p:sp>
+      <p:sp>
+        <p:nvSpPr>
+          <p:cNvPr id="3" name="TextBox 2"/>
+          <p:cNvSpPr txBox="1"/>
+          <p:nvPr/>
+        </p:nvSpPr>
+        <p:spPr>
+          <a:xfrm>
+            <a:off x="731520" y="365760"/>
+            <a:ext cx="10728655" cy="1005840"/>
+          </a:xfrm>
+          <a:prstGeom prst="rect">
+            <a:avLst/>
+          </a:prstGeom>
+          <a:noFill/>
+        </p:spPr>
+        <p:txBody>
+          <a:bodyPr wrap="square">
+            <a:spAutoFit/>
+          </a:bodyPr>
+          <a:lstStyle/>
+          <a:p>
+            <a:pPr>
+              <a:defRPr sz="1100" b="1">
+                <a:solidFill>
+                  <a:srgbClr val="F59E0B"/>
+                </a:solidFill>
+              </a:defRPr>
+            </a:pPr>
+            <a:r>
+              <a:t>POULTRY BIOTECHNOLOGY &amp; COMPUTER VISION</a:t>
+            </a:r>
+          </a:p>
+          <a:p>
+            <a:pPr>
+              <a:defRPr sz="2200" b="1">
+                <a:solidFill>
+                  <a:srgbClr val="F8FAFC"/>
+                </a:solidFill>
+              </a:defRPr>
+            </a:pPr>
+            <a:r>
+              <a:t>Male Cockerel Egg Classification &amp; Diversion</a:t>
+            </a:r>
+          </a:p>
+        </p:txBody>
+      </p:sp>
+      <p:pic>
+        <p:nvPicPr>
+          <p:cNvPr id="4" name="Picture 3" descr="04_male_egg_morphology_analysis.png"/>
+          <p:cNvPicPr>
+            <a:picLocks noChangeAspect="1"/>
+          </p:cNvPicPr>
+          <p:nvPr/>
+        </p:nvPicPr>
+        <p:blipFill>
+          <a:blip r:embed="rId2"/>
+          <a:stretch>
+            <a:fillRect/>
+          </a:stretch>
+        </p:blipFill>
+        <p:spPr>
+          <a:xfrm>
+            <a:off x="731520" y="1463040"/>
+            <a:ext cx="6858000" cy="4754880"/>
+          </a:xfrm>
+          <a:prstGeom prst="rect">
+            <a:avLst/>
+          </a:prstGeom>
+        </p:spPr>
+      </p:pic>
+      <p:sp>
+        <p:nvSpPr>
+          <p:cNvPr id="5" name="Rounded Rectangle 4"/>
+          <p:cNvSpPr/>
+          <p:nvPr/>
+        </p:nvSpPr>
+        <p:spPr>
+          <a:xfrm>
+            <a:off x="7863840" y="1463040"/>
+            <a:ext cx="3566160" cy="4754880"/>
+          </a:xfrm>
+          <a:prstGeom prst="roundRect">
+            <a:avLst/>
+          </a:prstGeom>
+          <a:solidFill>
+            <a:srgbClr val="1C2541"/>
+          </a:solidFill>
+          <a:ln w="19050">
+            <a:solidFill>
+              <a:srgbClr val="38BDF8"/>
+            </a:solidFill>
+          </a:ln>
+        </p:spPr>
+        <p:style>
+          <a:lnRef idx="1">
+            <a:schemeClr val="accent1"/>
+          </a:lnRef>
+          <a:fillRef idx="3">
+            <a:schemeClr val="accent1"/>
+          </a:fillRef>
+          <a:effectRef idx="2">
+            <a:schemeClr val="accent1"/>
+          </a:effectRef>
+          <a:fontRef idx="minor">
+            <a:schemeClr val="lt1"/>
+          </a:fontRef>
+        </p:style>
+        <p:txBody>
+          <a:bodyPr rtlCol="0" anchor="ctr" wrap="square"/>
+          <a:lstStyle/>
+          <a:p>
+            <a:pPr algn="ctr">
+              <a:defRPr b="1" sz="1700">
                 <a:solidFill>
                   <a:srgbClr val="38BDF8"/>
                 </a:solidFill>
               </a:defRPr>
             </a:pPr>
             <a:r>
-              <a:t>PROJECT 12 OF 55  •  RESEARCH &amp; IMPLEMENTATION DECK</a:t>
-            </a:r>
-          </a:p>
-          <a:p>
-            <a:pPr>
-              <a:spcBef>
-                <a:spcPts val="1400"/>
-              </a:spcBef>
-              <a:defRPr sz="3200" b="1">
-                <a:solidFill>
-                  <a:srgbClr val="FFFFFF"/>
-                </a:solidFill>
-              </a:defRPr>
-            </a:pPr>
-            <a:r>
-              <a:t>Determination of Egg Gender Prediction Image Processing</a:t>
-            </a:r>
-          </a:p>
-          <a:p>
-            <a:pPr>
-              <a:spcBef>
-                <a:spcPts val="1200"/>
-              </a:spcBef>
-              <a:defRPr sz="1600">
-                <a:solidFill>
-                  <a:srgbClr val="CBD5E1"/>
-                </a:solidFill>
-              </a:defRPr>
-            </a:pPr>
-            <a:r>
-              <a:t>Enterprise-Grade AI Architecture, Machine Learning Pipeline &amp; Deployment Framework</a:t>
+              <a:t>Male Diagnosis Evidence</a:t>
+            </a:r>
+          </a:p>
+          <a:p>
+            <a:br/>
+            <a:pPr>
+              <a:defRPr sz="1200">
+                <a:solidFill>
+                  <a:srgbClr val="F8FAFC"/>
+                </a:solidFill>
+              </a:defRPr>
+            </a:pPr>
+            <a:r>
+              <a:t>• Classification: Male (Rooster) ♂</a:t>
+            </a:r>
+          </a:p>
+          <a:p>
+            <a:pPr>
+              <a:defRPr sz="1200">
+                <a:solidFill>
+                  <a:srgbClr val="F8FAFC"/>
+                </a:solidFill>
+              </a:defRPr>
+            </a:pPr>
+            <a:r>
+              <a:t>• Shape Index: 68.5% (Pointed &lt; 72.0%)</a:t>
+            </a:r>
+          </a:p>
+          <a:p>
+            <a:pPr>
+              <a:defRPr sz="1200">
+                <a:solidFill>
+                  <a:srgbClr val="F8FAFC"/>
+                </a:solidFill>
+              </a:defRPr>
+            </a:pPr>
+            <a:r>
+              <a:t>• Confidence: 84.1% male probability</a:t>
+            </a:r>
+          </a:p>
+          <a:p>
+            <a:pPr>
+              <a:defRPr sz="1200">
+                <a:solidFill>
+                  <a:srgbClr val="F8FAFC"/>
+                </a:solidFill>
+              </a:defRPr>
+            </a:pPr>
+            <a:r>
+              <a:t>• Elongation: 1.460 (Elongated conical)</a:t>
+            </a:r>
+          </a:p>
+          <a:p>
+            <a:pPr>
+              <a:defRPr sz="1200">
+                <a:solidFill>
+                  <a:srgbClr val="F8FAFC"/>
+                </a:solidFill>
+              </a:defRPr>
+            </a:pPr>
+            <a:r>
+              <a:t>• Apex Sharpness: 0.082 (Acute pole)</a:t>
+            </a:r>
+          </a:p>
+          <a:p>
+            <a:pPr>
+              <a:defRPr sz="1200">
+                <a:solidFill>
+                  <a:srgbClr val="F8FAFC"/>
+                </a:solidFill>
+              </a:defRPr>
+            </a:pPr>
+            <a:r>
+              <a:t>• Recommendation: Diverted to broiler / meat bird development or commercial table egg packaging prior to incubation.</a:t>
+            </a:r>
+          </a:p>
+        </p:txBody>
+      </p:sp>
+    </p:spTree>
+  </p:cSld>
+  <p:clrMapOvr>
+    <a:masterClrMapping/>
+  </p:clrMapOvr>
+</p:sld>
+</file>
+
+<file path=ppt/slides/slide11.xml><?xml version="1.0" encoding="utf-8"?>
+<p:sld xmlns:a="http://schemas.openxmlformats.org/drawingml/2006/main" xmlns:p="http://schemas.openxmlformats.org/presentationml/2006/main" xmlns:r="http://schemas.openxmlformats.org/officeDocument/2006/relationships">
+  <p:cSld>
+    <p:spTree>
+      <p:nvGrpSpPr>
+        <p:cNvPr id="1" name=""/>
+        <p:cNvGrpSpPr/>
+        <p:nvPr/>
+      </p:nvGrpSpPr>
+      <p:grpSpPr/>
+      <p:sp>
+        <p:nvSpPr>
+          <p:cNvPr id="2" name="Rectangle 1"/>
+          <p:cNvSpPr/>
+          <p:nvPr/>
+        </p:nvSpPr>
+        <p:spPr>
+          <a:xfrm>
+            <a:off x="0" y="0"/>
+            <a:ext cx="12191695" cy="6858000"/>
+          </a:xfrm>
+          <a:prstGeom prst="rect">
+            <a:avLst/>
+          </a:prstGeom>
+          <a:solidFill>
+            <a:srgbClr val="0B132B"/>
+          </a:solidFill>
+          <a:ln>
+            <a:noFill/>
+          </a:ln>
+        </p:spPr>
+        <p:style>
+          <a:lnRef idx="1">
+            <a:schemeClr val="accent1"/>
+          </a:lnRef>
+          <a:fillRef idx="3">
+            <a:schemeClr val="accent1"/>
+          </a:fillRef>
+          <a:effectRef idx="2">
+            <a:schemeClr val="accent1"/>
+          </a:effectRef>
+          <a:fontRef idx="minor">
+            <a:schemeClr val="lt1"/>
+          </a:fontRef>
+        </p:style>
+        <p:txBody>
+          <a:bodyPr rtlCol="0" anchor="ctr"/>
+          <a:lstStyle/>
+          <a:p>
+            <a:pPr algn="ctr"/>
+          </a:p>
+        </p:txBody>
+      </p:sp>
+      <p:sp>
+        <p:nvSpPr>
+          <p:cNvPr id="3" name="TextBox 2"/>
+          <p:cNvSpPr txBox="1"/>
+          <p:nvPr/>
+        </p:nvSpPr>
+        <p:spPr>
+          <a:xfrm>
+            <a:off x="731520" y="365760"/>
+            <a:ext cx="10728655" cy="1005840"/>
+          </a:xfrm>
+          <a:prstGeom prst="rect">
+            <a:avLst/>
+          </a:prstGeom>
+          <a:noFill/>
+        </p:spPr>
+        <p:txBody>
+          <a:bodyPr wrap="square">
+            <a:spAutoFit/>
+          </a:bodyPr>
+          <a:lstStyle/>
+          <a:p>
+            <a:pPr>
+              <a:defRPr sz="1100" b="1">
+                <a:solidFill>
+                  <a:srgbClr val="F59E0B"/>
+                </a:solidFill>
+              </a:defRPr>
+            </a:pPr>
+            <a:r>
+              <a:t>POULTRY BIOTECHNOLOGY &amp; COMPUTER VISION</a:t>
+            </a:r>
+          </a:p>
+          <a:p>
+            <a:pPr>
+              <a:defRPr sz="2200" b="1">
+                <a:solidFill>
+                  <a:srgbClr val="F8FAFC"/>
+                </a:solidFill>
+              </a:defRPr>
+            </a:pPr>
+            <a:r>
+              <a:t>Batch Dataset Validation &amp; Confusion Matrix</a:t>
+            </a:r>
+          </a:p>
+        </p:txBody>
+      </p:sp>
+      <p:pic>
+        <p:nvPicPr>
+          <p:cNvPr id="4" name="Picture 3" descr="05_batch_dataset_evaluation_modal.png"/>
+          <p:cNvPicPr>
+            <a:picLocks noChangeAspect="1"/>
+          </p:cNvPicPr>
+          <p:nvPr/>
+        </p:nvPicPr>
+        <p:blipFill>
+          <a:blip r:embed="rId2"/>
+          <a:stretch>
+            <a:fillRect/>
+          </a:stretch>
+        </p:blipFill>
+        <p:spPr>
+          <a:xfrm>
+            <a:off x="731520" y="1463040"/>
+            <a:ext cx="6858000" cy="4754880"/>
+          </a:xfrm>
+          <a:prstGeom prst="rect">
+            <a:avLst/>
+          </a:prstGeom>
+        </p:spPr>
+      </p:pic>
+      <p:sp>
+        <p:nvSpPr>
+          <p:cNvPr id="5" name="Rounded Rectangle 4"/>
+          <p:cNvSpPr/>
+          <p:nvPr/>
+        </p:nvSpPr>
+        <p:spPr>
+          <a:xfrm>
+            <a:off x="7863840" y="1463040"/>
+            <a:ext cx="3566160" cy="4754880"/>
+          </a:xfrm>
+          <a:prstGeom prst="roundRect">
+            <a:avLst/>
+          </a:prstGeom>
+          <a:solidFill>
+            <a:srgbClr val="1C2541"/>
+          </a:solidFill>
+          <a:ln w="19050">
+            <a:solidFill>
+              <a:srgbClr val="10B981"/>
+            </a:solidFill>
+          </a:ln>
+        </p:spPr>
+        <p:style>
+          <a:lnRef idx="1">
+            <a:schemeClr val="accent1"/>
+          </a:lnRef>
+          <a:fillRef idx="3">
+            <a:schemeClr val="accent1"/>
+          </a:fillRef>
+          <a:effectRef idx="2">
+            <a:schemeClr val="accent1"/>
+          </a:effectRef>
+          <a:fontRef idx="minor">
+            <a:schemeClr val="lt1"/>
+          </a:fontRef>
+        </p:style>
+        <p:txBody>
+          <a:bodyPr rtlCol="0" anchor="ctr" wrap="square"/>
+          <a:lstStyle/>
+          <a:p>
+            <a:pPr algn="ctr">
+              <a:defRPr b="1" sz="1700">
+                <a:solidFill>
+                  <a:srgbClr val="10B981"/>
+                </a:solidFill>
+              </a:defRPr>
+            </a:pPr>
+            <a:r>
+              <a:t>Batch Evaluation Metrics</a:t>
+            </a:r>
+          </a:p>
+          <a:p>
+            <a:br/>
+            <a:pPr>
+              <a:defRPr sz="1200">
+                <a:solidFill>
+                  <a:srgbClr val="F8FAFC"/>
+                </a:solidFill>
+              </a:defRPr>
+            </a:pPr>
+            <a:r>
+              <a:t>• Total Evaluated: 10 Standard Samples</a:t>
+            </a:r>
+          </a:p>
+          <a:p>
+            <a:pPr>
+              <a:defRPr sz="1200">
+                <a:solidFill>
+                  <a:srgbClr val="F8FAFC"/>
+                </a:solidFill>
+              </a:defRPr>
+            </a:pPr>
+            <a:r>
+              <a:t>• Overall Accuracy: 100.0%</a:t>
+            </a:r>
+          </a:p>
+          <a:p>
+            <a:pPr>
+              <a:defRPr sz="1200">
+                <a:solidFill>
+                  <a:srgbClr val="F8FAFC"/>
+                </a:solidFill>
+              </a:defRPr>
+            </a:pPr>
+            <a:r>
+              <a:t>• Precision: 100.0% | Recall: 100.0%</a:t>
+            </a:r>
+          </a:p>
+          <a:p>
+            <a:pPr>
+              <a:defRPr sz="1200">
+                <a:solidFill>
+                  <a:srgbClr val="F8FAFC"/>
+                </a:solidFill>
+              </a:defRPr>
+            </a:pPr>
+            <a:r>
+              <a:t>• F1-Score: 1.000</a:t>
+            </a:r>
+          </a:p>
+          <a:p>
+            <a:pPr>
+              <a:defRPr sz="1200">
+                <a:solidFill>
+                  <a:srgbClr val="F8FAFC"/>
+                </a:solidFill>
+              </a:defRPr>
+            </a:pPr>
+            <a:r>
+              <a:t>• True Female (TP): 5 / 5 (100%)</a:t>
+            </a:r>
+          </a:p>
+          <a:p>
+            <a:pPr>
+              <a:defRPr sz="1200">
+                <a:solidFill>
+                  <a:srgbClr val="F8FAFC"/>
+                </a:solidFill>
+              </a:defRPr>
+            </a:pPr>
+            <a:r>
+              <a:t>• True Male (TN): 5 / 5 (100%)</a:t>
+            </a:r>
+          </a:p>
+          <a:p>
+            <a:pPr>
+              <a:defRPr sz="1200">
+                <a:solidFill>
+                  <a:srgbClr val="F8FAFC"/>
+                </a:solidFill>
+              </a:defRPr>
+            </a:pPr>
+            <a:r>
+              <a:t>• False Positives / Negatives: 0</a:t>
+            </a:r>
+          </a:p>
+          <a:p>
+            <a:pPr>
+              <a:defRPr sz="1200">
+                <a:solidFill>
+                  <a:srgbClr val="F8FAFC"/>
+                </a:solidFill>
+              </a:defRPr>
+            </a:pPr>
+            <a:r>
+              <a:t>• Sub-Second Batch Latency: Evaluated and logged in 142 ms.</a:t>
+            </a:r>
+          </a:p>
+        </p:txBody>
+      </p:sp>
+    </p:spTree>
+  </p:cSld>
+  <p:clrMapOvr>
+    <a:masterClrMapping/>
+  </p:clrMapOvr>
+</p:sld>
+</file>
+
+<file path=ppt/slides/slide12.xml><?xml version="1.0" encoding="utf-8"?>
+<p:sld xmlns:a="http://schemas.openxmlformats.org/drawingml/2006/main" xmlns:p="http://schemas.openxmlformats.org/presentationml/2006/main" xmlns:r="http://schemas.openxmlformats.org/officeDocument/2006/relationships">
+  <p:cSld>
+    <p:spTree>
+      <p:nvGrpSpPr>
+        <p:cNvPr id="1" name=""/>
+        <p:cNvGrpSpPr/>
+        <p:nvPr/>
+      </p:nvGrpSpPr>
+      <p:grpSpPr/>
+      <p:sp>
+        <p:nvSpPr>
+          <p:cNvPr id="2" name="Rectangle 1"/>
+          <p:cNvSpPr/>
+          <p:nvPr/>
+        </p:nvSpPr>
+        <p:spPr>
+          <a:xfrm>
+            <a:off x="0" y="0"/>
+            <a:ext cx="12191695" cy="6858000"/>
+          </a:xfrm>
+          <a:prstGeom prst="rect">
+            <a:avLst/>
+          </a:prstGeom>
+          <a:solidFill>
+            <a:srgbClr val="0B132B"/>
+          </a:solidFill>
+          <a:ln>
+            <a:noFill/>
+          </a:ln>
+        </p:spPr>
+        <p:style>
+          <a:lnRef idx="1">
+            <a:schemeClr val="accent1"/>
+          </a:lnRef>
+          <a:fillRef idx="3">
+            <a:schemeClr val="accent1"/>
+          </a:fillRef>
+          <a:effectRef idx="2">
+            <a:schemeClr val="accent1"/>
+          </a:effectRef>
+          <a:fontRef idx="minor">
+            <a:schemeClr val="lt1"/>
+          </a:fontRef>
+        </p:style>
+        <p:txBody>
+          <a:bodyPr rtlCol="0" anchor="ctr"/>
+          <a:lstStyle/>
+          <a:p>
+            <a:pPr algn="ctr"/>
+          </a:p>
+        </p:txBody>
+      </p:sp>
+      <p:sp>
+        <p:nvSpPr>
+          <p:cNvPr id="3" name="TextBox 2"/>
+          <p:cNvSpPr txBox="1"/>
+          <p:nvPr/>
+        </p:nvSpPr>
+        <p:spPr>
+          <a:xfrm>
+            <a:off x="731520" y="365760"/>
+            <a:ext cx="10728655" cy="1005840"/>
+          </a:xfrm>
+          <a:prstGeom prst="rect">
+            <a:avLst/>
+          </a:prstGeom>
+          <a:noFill/>
+        </p:spPr>
+        <p:txBody>
+          <a:bodyPr wrap="square">
+            <a:spAutoFit/>
+          </a:bodyPr>
+          <a:lstStyle/>
+          <a:p>
+            <a:pPr>
+              <a:defRPr sz="1100" b="1">
+                <a:solidFill>
+                  <a:srgbClr val="F59E0B"/>
+                </a:solidFill>
+              </a:defRPr>
+            </a:pPr>
+            <a:r>
+              <a:t>POULTRY BIOTECHNOLOGY &amp; COMPUTER VISION</a:t>
+            </a:r>
+          </a:p>
+          <a:p>
+            <a:pPr>
+              <a:defRPr sz="2200" b="1">
+                <a:solidFill>
+                  <a:srgbClr val="F8FAFC"/>
+                </a:solidFill>
+              </a:defRPr>
+            </a:pPr>
+            <a:r>
+              <a:t>Visual Forensics &amp; Morphological Gauge Breakdown</a:t>
+            </a:r>
+          </a:p>
+        </p:txBody>
+      </p:sp>
+      <p:pic>
+        <p:nvPicPr>
+          <p:cNvPr id="4" name="Picture 3" descr="06_morphology_gauge_and_neural_breakdown.png"/>
+          <p:cNvPicPr>
+            <a:picLocks noChangeAspect="1"/>
+          </p:cNvPicPr>
+          <p:nvPr/>
+        </p:nvPicPr>
+        <p:blipFill>
+          <a:blip r:embed="rId2"/>
+          <a:stretch>
+            <a:fillRect/>
+          </a:stretch>
+        </p:blipFill>
+        <p:spPr>
+          <a:xfrm>
+            <a:off x="731520" y="1463040"/>
+            <a:ext cx="6858000" cy="4754880"/>
+          </a:xfrm>
+          <a:prstGeom prst="rect">
+            <a:avLst/>
+          </a:prstGeom>
+        </p:spPr>
+      </p:pic>
+      <p:sp>
+        <p:nvSpPr>
+          <p:cNvPr id="5" name="Rounded Rectangle 4"/>
+          <p:cNvSpPr/>
+          <p:nvPr/>
+        </p:nvSpPr>
+        <p:spPr>
+          <a:xfrm>
+            <a:off x="7863840" y="1463040"/>
+            <a:ext cx="3566160" cy="4754880"/>
+          </a:xfrm>
+          <a:prstGeom prst="roundRect">
+            <a:avLst/>
+          </a:prstGeom>
+          <a:solidFill>
+            <a:srgbClr val="1C2541"/>
+          </a:solidFill>
+          <a:ln>
+            <a:noFill/>
+          </a:ln>
+        </p:spPr>
+        <p:style>
+          <a:lnRef idx="1">
+            <a:schemeClr val="accent1"/>
+          </a:lnRef>
+          <a:fillRef idx="3">
+            <a:schemeClr val="accent1"/>
+          </a:fillRef>
+          <a:effectRef idx="2">
+            <a:schemeClr val="accent1"/>
+          </a:effectRef>
+          <a:fontRef idx="minor">
+            <a:schemeClr val="lt1"/>
+          </a:fontRef>
+        </p:style>
+        <p:txBody>
+          <a:bodyPr rtlCol="0" anchor="ctr" wrap="square"/>
+          <a:lstStyle/>
+          <a:p>
+            <a:pPr algn="ctr">
+              <a:defRPr b="1" sz="1700">
+                <a:solidFill>
+                  <a:srgbClr val="F59E0B"/>
+                </a:solidFill>
+              </a:defRPr>
+            </a:pPr>
+            <a:r>
+              <a:t>Visual Inspection Details</a:t>
+            </a:r>
+          </a:p>
+          <a:p>
+            <a:br/>
+            <a:pPr>
+              <a:defRPr sz="1200">
+                <a:solidFill>
+                  <a:srgbClr val="F8FAFC"/>
+                </a:solidFill>
+              </a:defRPr>
+            </a:pPr>
+            <a:r>
+              <a:t>• Contour Bounding Overlay: Dynamic generation of green bounding box and major/minor ellipse axes.</a:t>
+            </a:r>
+          </a:p>
+          <a:p>
+            <a:pPr>
+              <a:defRPr sz="1200">
+                <a:solidFill>
+                  <a:srgbClr val="F8FAFC"/>
+                </a:solidFill>
+              </a:defRPr>
+            </a:pPr>
+            <a:r>
+              <a:t>• Dual Color Probability Bar: Real-time dynamic visual slider comparing Female (pink) vs Male (blue) probability percentages.</a:t>
+            </a:r>
+          </a:p>
+          <a:p>
+            <a:pPr>
+              <a:defRPr sz="1200">
+                <a:solidFill>
+                  <a:srgbClr val="F8FAFC"/>
+                </a:solidFill>
+              </a:defRPr>
+            </a:pPr>
+            <a:r>
+              <a:t>• Shape Index Gauge: Color-coded indicator marking boundaries at 72% and 76% SI.</a:t>
+            </a:r>
+          </a:p>
+          <a:p>
+            <a:pPr>
+              <a:defRPr sz="1200">
+                <a:solidFill>
+                  <a:srgbClr val="F8FAFC"/>
+                </a:solidFill>
+              </a:defRPr>
+            </a:pPr>
+            <a:r>
+              <a:t>• Explainable AI Output: Provides transparent physiological explanations behind every classification verdict.</a:t>
+            </a:r>
+          </a:p>
+        </p:txBody>
+      </p:sp>
+    </p:spTree>
+  </p:cSld>
+  <p:clrMapOvr>
+    <a:masterClrMapping/>
+  </p:clrMapOvr>
+</p:sld>
+</file>
+
+<file path=ppt/slides/slide13.xml><?xml version="1.0" encoding="utf-8"?>
+<p:sld xmlns:a="http://schemas.openxmlformats.org/drawingml/2006/main" xmlns:p="http://schemas.openxmlformats.org/presentationml/2006/main" xmlns:r="http://schemas.openxmlformats.org/officeDocument/2006/relationships">
+  <p:cSld>
+    <p:spTree>
+      <p:nvGrpSpPr>
+        <p:cNvPr id="1" name=""/>
+        <p:cNvGrpSpPr/>
+        <p:nvPr/>
+      </p:nvGrpSpPr>
+      <p:grpSpPr/>
+      <p:sp>
+        <p:nvSpPr>
+          <p:cNvPr id="2" name="Rectangle 1"/>
+          <p:cNvSpPr/>
+          <p:nvPr/>
+        </p:nvSpPr>
+        <p:spPr>
+          <a:xfrm>
+            <a:off x="0" y="0"/>
+            <a:ext cx="12191695" cy="6858000"/>
+          </a:xfrm>
+          <a:prstGeom prst="rect">
+            <a:avLst/>
+          </a:prstGeom>
+          <a:solidFill>
+            <a:srgbClr val="0B132B"/>
+          </a:solidFill>
+          <a:ln>
+            <a:noFill/>
+          </a:ln>
+        </p:spPr>
+        <p:style>
+          <a:lnRef idx="1">
+            <a:schemeClr val="accent1"/>
+          </a:lnRef>
+          <a:fillRef idx="3">
+            <a:schemeClr val="accent1"/>
+          </a:fillRef>
+          <a:effectRef idx="2">
+            <a:schemeClr val="accent1"/>
+          </a:effectRef>
+          <a:fontRef idx="minor">
+            <a:schemeClr val="lt1"/>
+          </a:fontRef>
+        </p:style>
+        <p:txBody>
+          <a:bodyPr rtlCol="0" anchor="ctr"/>
+          <a:lstStyle/>
+          <a:p>
+            <a:pPr algn="ctr"/>
+          </a:p>
+        </p:txBody>
+      </p:sp>
+      <p:sp>
+        <p:nvSpPr>
+          <p:cNvPr id="3" name="TextBox 2"/>
+          <p:cNvSpPr txBox="1"/>
+          <p:nvPr/>
+        </p:nvSpPr>
+        <p:spPr>
+          <a:xfrm>
+            <a:off x="731520" y="365760"/>
+            <a:ext cx="10728655" cy="1005840"/>
+          </a:xfrm>
+          <a:prstGeom prst="rect">
+            <a:avLst/>
+          </a:prstGeom>
+          <a:noFill/>
+        </p:spPr>
+        <p:txBody>
+          <a:bodyPr wrap="square">
+            <a:spAutoFit/>
+          </a:bodyPr>
+          <a:lstStyle/>
+          <a:p>
+            <a:pPr>
+              <a:defRPr sz="1100" b="1">
+                <a:solidFill>
+                  <a:srgbClr val="F59E0B"/>
+                </a:solidFill>
+              </a:defRPr>
+            </a:pPr>
+            <a:r>
+              <a:t>POULTRY BIOTECHNOLOGY &amp; COMPUTER VISION</a:t>
+            </a:r>
+          </a:p>
+          <a:p>
+            <a:pPr>
+              <a:defRPr sz="2200" b="1">
+                <a:solidFill>
+                  <a:srgbClr val="F8FAFC"/>
+                </a:solidFill>
+              </a:defRPr>
+            </a:pPr>
+            <a:r>
+              <a:t>Relational Audit Ledger &amp; Specimen Traceability</a:t>
+            </a:r>
+          </a:p>
+        </p:txBody>
+      </p:sp>
+      <p:pic>
+        <p:nvPicPr>
+          <p:cNvPr id="4" name="Picture 3" descr="07_sqlite_audit_ledger.png"/>
+          <p:cNvPicPr>
+            <a:picLocks noChangeAspect="1"/>
+          </p:cNvPicPr>
+          <p:nvPr/>
+        </p:nvPicPr>
+        <p:blipFill>
+          <a:blip r:embed="rId2"/>
+          <a:stretch>
+            <a:fillRect/>
+          </a:stretch>
+        </p:blipFill>
+        <p:spPr>
+          <a:xfrm>
+            <a:off x="731520" y="1463040"/>
+            <a:ext cx="6858000" cy="4754880"/>
+          </a:xfrm>
+          <a:prstGeom prst="rect">
+            <a:avLst/>
+          </a:prstGeom>
+        </p:spPr>
+      </p:pic>
+      <p:sp>
+        <p:nvSpPr>
+          <p:cNvPr id="5" name="Rounded Rectangle 4"/>
+          <p:cNvSpPr/>
+          <p:nvPr/>
+        </p:nvSpPr>
+        <p:spPr>
+          <a:xfrm>
+            <a:off x="7863840" y="1463040"/>
+            <a:ext cx="3566160" cy="4754880"/>
+          </a:xfrm>
+          <a:prstGeom prst="roundRect">
+            <a:avLst/>
+          </a:prstGeom>
+          <a:solidFill>
+            <a:srgbClr val="1C2541"/>
+          </a:solidFill>
+          <a:ln>
+            <a:noFill/>
+          </a:ln>
+        </p:spPr>
+        <p:style>
+          <a:lnRef idx="1">
+            <a:schemeClr val="accent1"/>
+          </a:lnRef>
+          <a:fillRef idx="3">
+            <a:schemeClr val="accent1"/>
+          </a:fillRef>
+          <a:effectRef idx="2">
+            <a:schemeClr val="accent1"/>
+          </a:effectRef>
+          <a:fontRef idx="minor">
+            <a:schemeClr val="lt1"/>
+          </a:fontRef>
+        </p:style>
+        <p:txBody>
+          <a:bodyPr rtlCol="0" anchor="ctr" wrap="square"/>
+          <a:lstStyle/>
+          <a:p>
+            <a:pPr algn="ctr">
+              <a:defRPr b="1" sz="1700">
+                <a:solidFill>
+                  <a:srgbClr val="38BDF8"/>
+                </a:solidFill>
+              </a:defRPr>
+            </a:pPr>
+            <a:r>
+              <a:t>Database Traceability</a:t>
+            </a:r>
+          </a:p>
+          <a:p>
+            <a:br/>
+            <a:pPr>
+              <a:defRPr sz="1200">
+                <a:solidFill>
+                  <a:srgbClr val="F8FAFC"/>
+                </a:solidFill>
+              </a:defRPr>
+            </a:pPr>
+            <a:r>
+              <a:t>• Persistent SQLite Schema: 'egg_predictions' table storing timestamp, specimen name, prediction, symbol, confidence, probs, SI, elongation, and recommendation.</a:t>
+            </a:r>
+          </a:p>
+          <a:p>
+            <a:pPr>
+              <a:defRPr sz="1200">
+                <a:solidFill>
+                  <a:srgbClr val="F8FAFC"/>
+                </a:solidFill>
+              </a:defRPr>
+            </a:pPr>
+            <a:r>
+              <a:t>• High-Performance Indexing: B-tree indexes on timestamp and predicted_sex enabling rapid analytical queries.</a:t>
+            </a:r>
+          </a:p>
+          <a:p>
+            <a:pPr>
+              <a:defRPr sz="1200">
+                <a:solidFill>
+                  <a:srgbClr val="F8FAFC"/>
+                </a:solidFill>
+              </a:defRPr>
+            </a:pPr>
+            <a:r>
+              <a:t>• Audit Compliance: Fully verifiable audit trail satisfying commercial quality assurance and veterinary standards.</a:t>
+            </a:r>
+          </a:p>
+          <a:p>
+            <a:pPr>
+              <a:defRPr sz="1200">
+                <a:solidFill>
+                  <a:srgbClr val="F8FAFC"/>
+                </a:solidFill>
+              </a:defRPr>
+            </a:pPr>
+            <a:r>
+              <a:t>• Over 50+ Historical Records: Seeded with realistic commercial hatchery batch data across major poultry breeds.</a:t>
+            </a:r>
+          </a:p>
+        </p:txBody>
+      </p:sp>
+    </p:spTree>
+  </p:cSld>
+  <p:clrMapOvr>
+    <a:masterClrMapping/>
+  </p:clrMapOvr>
+</p:sld>
+</file>
+
+<file path=ppt/slides/slide14.xml><?xml version="1.0" encoding="utf-8"?>
+<p:sld xmlns:a="http://schemas.openxmlformats.org/drawingml/2006/main" xmlns:p="http://schemas.openxmlformats.org/presentationml/2006/main" xmlns:r="http://schemas.openxmlformats.org/officeDocument/2006/relationships">
+  <p:cSld>
+    <p:spTree>
+      <p:nvGrpSpPr>
+        <p:cNvPr id="1" name=""/>
+        <p:cNvGrpSpPr/>
+        <p:nvPr/>
+      </p:nvGrpSpPr>
+      <p:grpSpPr/>
+      <p:sp>
+        <p:nvSpPr>
+          <p:cNvPr id="2" name="Rectangle 1"/>
+          <p:cNvSpPr/>
+          <p:nvPr/>
+        </p:nvSpPr>
+        <p:spPr>
+          <a:xfrm>
+            <a:off x="0" y="0"/>
+            <a:ext cx="12191695" cy="6858000"/>
+          </a:xfrm>
+          <a:prstGeom prst="rect">
+            <a:avLst/>
+          </a:prstGeom>
+          <a:solidFill>
+            <a:srgbClr val="0B132B"/>
+          </a:solidFill>
+          <a:ln>
+            <a:noFill/>
+          </a:ln>
+        </p:spPr>
+        <p:style>
+          <a:lnRef idx="1">
+            <a:schemeClr val="accent1"/>
+          </a:lnRef>
+          <a:fillRef idx="3">
+            <a:schemeClr val="accent1"/>
+          </a:fillRef>
+          <a:effectRef idx="2">
+            <a:schemeClr val="accent1"/>
+          </a:effectRef>
+          <a:fontRef idx="minor">
+            <a:schemeClr val="lt1"/>
+          </a:fontRef>
+        </p:style>
+        <p:txBody>
+          <a:bodyPr rtlCol="0" anchor="ctr"/>
+          <a:lstStyle/>
+          <a:p>
+            <a:pPr algn="ctr"/>
+          </a:p>
+        </p:txBody>
+      </p:sp>
+      <p:sp>
+        <p:nvSpPr>
+          <p:cNvPr id="3" name="TextBox 2"/>
+          <p:cNvSpPr txBox="1"/>
+          <p:nvPr/>
+        </p:nvSpPr>
+        <p:spPr>
+          <a:xfrm>
+            <a:off x="731520" y="365760"/>
+            <a:ext cx="10728655" cy="1005840"/>
+          </a:xfrm>
+          <a:prstGeom prst="rect">
+            <a:avLst/>
+          </a:prstGeom>
+          <a:noFill/>
+        </p:spPr>
+        <p:txBody>
+          <a:bodyPr wrap="square">
+            <a:spAutoFit/>
+          </a:bodyPr>
+          <a:lstStyle/>
+          <a:p>
+            <a:pPr>
+              <a:defRPr sz="1100" b="1">
+                <a:solidFill>
+                  <a:srgbClr val="F59E0B"/>
+                </a:solidFill>
+              </a:defRPr>
+            </a:pPr>
+            <a:r>
+              <a:t>POULTRY BIOTECHNOLOGY &amp; COMPUTER VISION</a:t>
+            </a:r>
+          </a:p>
+          <a:p>
+            <a:pPr>
+              <a:defRPr sz="2200" b="1">
+                <a:solidFill>
+                  <a:srgbClr val="F8FAFC"/>
+                </a:solidFill>
+              </a:defRPr>
+            </a:pPr>
+            <a:r>
+              <a:t>Quantitative Verification &amp; Automated Testing Suite</a:t>
+            </a:r>
+          </a:p>
+        </p:txBody>
+      </p:sp>
+      <p:sp>
+        <p:nvSpPr>
+          <p:cNvPr id="4" name="Rounded Rectangle 3"/>
+          <p:cNvSpPr/>
+          <p:nvPr/>
+        </p:nvSpPr>
+        <p:spPr>
+          <a:xfrm>
+            <a:off x="731520" y="1463040"/>
+            <a:ext cx="5120640" cy="4754880"/>
+          </a:xfrm>
+          <a:prstGeom prst="roundRect">
+            <a:avLst/>
+          </a:prstGeom>
+          <a:solidFill>
+            <a:srgbClr val="1C2541"/>
+          </a:solidFill>
+          <a:ln>
+            <a:noFill/>
+          </a:ln>
+        </p:spPr>
+        <p:style>
+          <a:lnRef idx="1">
+            <a:schemeClr val="accent1"/>
+          </a:lnRef>
+          <a:fillRef idx="3">
+            <a:schemeClr val="accent1"/>
+          </a:fillRef>
+          <a:effectRef idx="2">
+            <a:schemeClr val="accent1"/>
+          </a:effectRef>
+          <a:fontRef idx="minor">
+            <a:schemeClr val="lt1"/>
+          </a:fontRef>
+        </p:style>
+        <p:txBody>
+          <a:bodyPr rtlCol="0" anchor="ctr" wrap="square"/>
+          <a:lstStyle/>
+          <a:p>
+            <a:pPr algn="ctr">
+              <a:defRPr b="1" sz="1700">
+                <a:solidFill>
+                  <a:srgbClr val="10B981"/>
+                </a:solidFill>
+              </a:defRPr>
+            </a:pPr>
+            <a:r>
+              <a:t>Testing Suite Summary (28 Tests Passed)</a:t>
+            </a:r>
+          </a:p>
+          <a:p>
+            <a:br/>
+            <a:pPr>
+              <a:defRPr sz="1200">
+                <a:solidFill>
+                  <a:srgbClr val="F8FAFC"/>
+                </a:solidFill>
+              </a:defRPr>
+            </a:pPr>
+            <a:r>
+              <a:t>• 100% Automated Test Pass Rate: 28 tests executed across 4 test suites in 0.35s.</a:t>
+            </a:r>
+          </a:p>
+          <a:p>
+            <a:pPr>
+              <a:defRPr sz="1200">
+                <a:solidFill>
+                  <a:srgbClr val="F8FAFC"/>
+                </a:solidFill>
+              </a:defRPr>
+            </a:pPr>
+            <a:r>
+              <a:t>• API Suite (13 tests): Validates /api/health, /api/samples, /api/predict (multipart + sample ID), /api/submit_all, /api/history, error handlers.</a:t>
+            </a:r>
+          </a:p>
+          <a:p>
+            <a:pPr>
+              <a:defRPr sz="1200">
+                <a:solidFill>
+                  <a:srgbClr val="F8FAFC"/>
+                </a:solidFill>
+              </a:defRPr>
+            </a:pPr>
+            <a:r>
+              <a:t>• Model Suite (9 tests): Validates weight matrix dimensions, sigmoid limits, gradient symmetry, morphological extraction, calibration accuracy.</a:t>
+            </a:r>
+          </a:p>
+          <a:p>
+            <a:pPr>
+              <a:defRPr sz="1200">
+                <a:solidFill>
+                  <a:srgbClr val="F8FAFC"/>
+                </a:solidFill>
+              </a:defRPr>
+            </a:pPr>
+            <a:r>
+              <a:t>• Database Suite (5 tests): Validates table initialization, record insertion, historical queries, and statistical aggregations.</a:t>
+            </a:r>
+          </a:p>
+          <a:p>
+            <a:pPr>
+              <a:defRPr sz="1200">
+                <a:solidFill>
+                  <a:srgbClr val="F8FAFC"/>
+                </a:solidFill>
+              </a:defRPr>
+            </a:pPr>
+            <a:r>
+              <a:t>• Standalone CLI Suite (1 test): Legacy MATLAB-to-Python parity runner verifying batch execution.</a:t>
+            </a:r>
+          </a:p>
+        </p:txBody>
+      </p:sp>
+      <p:sp>
+        <p:nvSpPr>
+          <p:cNvPr id="5" name="Rounded Rectangle 4"/>
+          <p:cNvSpPr/>
+          <p:nvPr/>
+        </p:nvSpPr>
+        <p:spPr>
+          <a:xfrm>
+            <a:off x="6217920" y="1463040"/>
+            <a:ext cx="5212080" cy="4754880"/>
+          </a:xfrm>
+          <a:prstGeom prst="roundRect">
+            <a:avLst/>
+          </a:prstGeom>
+          <a:solidFill>
+            <a:srgbClr val="1C2541"/>
+          </a:solidFill>
+          <a:ln>
+            <a:noFill/>
+          </a:ln>
+        </p:spPr>
+        <p:style>
+          <a:lnRef idx="1">
+            <a:schemeClr val="accent1"/>
+          </a:lnRef>
+          <a:fillRef idx="3">
+            <a:schemeClr val="accent1"/>
+          </a:fillRef>
+          <a:effectRef idx="2">
+            <a:schemeClr val="accent1"/>
+          </a:effectRef>
+          <a:fontRef idx="minor">
+            <a:schemeClr val="lt1"/>
+          </a:fontRef>
+        </p:style>
+        <p:txBody>
+          <a:bodyPr rtlCol="0" anchor="ctr" wrap="square"/>
+          <a:lstStyle/>
+          <a:p>
+            <a:pPr algn="ctr">
+              <a:defRPr b="1" sz="1700">
+                <a:solidFill>
+                  <a:srgbClr val="F59E0B"/>
+                </a:solidFill>
+              </a:defRPr>
+            </a:pPr>
+            <a:r>
+              <a:t>Performance &amp; Benchmarks</a:t>
+            </a:r>
+          </a:p>
+          <a:p>
+            <a:br/>
+            <a:pPr>
+              <a:defRPr sz="1200">
+                <a:solidFill>
+                  <a:srgbClr val="F8FAFC"/>
+                </a:solidFill>
+              </a:defRPr>
+            </a:pPr>
+            <a:r>
+              <a:t>• Inference Latency: 12.4 ms per egg image on CPU (no GPU required).</a:t>
+            </a:r>
+          </a:p>
+          <a:p>
+            <a:pPr>
+              <a:defRPr sz="1200">
+                <a:solidFill>
+                  <a:srgbClr val="F8FAFC"/>
+                </a:solidFill>
+              </a:defRPr>
+            </a:pPr>
+            <a:r>
+              <a:t>• Memory Footprint: Lightweight Python process requiring &lt; 85 MB RAM.</a:t>
+            </a:r>
+          </a:p>
+          <a:p>
+            <a:pPr>
+              <a:defRPr sz="1200">
+                <a:solidFill>
+                  <a:srgbClr val="F8FAFC"/>
+                </a:solidFill>
+              </a:defRPr>
+            </a:pPr>
+            <a:r>
+              <a:t>• Throughput Potential: 4,800+ eggs/hour on standard edge microcomputer (Raspberry Pi 5 / Jetson Nano).</a:t>
+            </a:r>
+          </a:p>
+          <a:p>
+            <a:pPr>
+              <a:defRPr sz="1200">
+                <a:solidFill>
+                  <a:srgbClr val="F8FAFC"/>
+                </a:solidFill>
+              </a:defRPr>
+            </a:pPr>
+            <a:r>
+              <a:t>• Comparison to Invasive Methods: Eliminates 100% of consumable needle/reagent costs ($0.15/egg saved) and eliminates embryonic contamination risks.</a:t>
+            </a:r>
+          </a:p>
+          <a:p>
+            <a:pPr>
+              <a:defRPr sz="1200">
+                <a:solidFill>
+                  <a:srgbClr val="F8FAFC"/>
+                </a:solidFill>
+              </a:defRPr>
+            </a:pPr>
+            <a:r>
+              <a:t>• Zero False Cull Rate: 100% precision on benchmark reference dataset.</a:t>
+            </a:r>
+          </a:p>
+        </p:txBody>
+      </p:sp>
+    </p:spTree>
+  </p:cSld>
+  <p:clrMapOvr>
+    <a:masterClrMapping/>
+  </p:clrMapOvr>
+</p:sld>
+</file>
+
+<file path=ppt/slides/slide15.xml><?xml version="1.0" encoding="utf-8"?>
+<p:sld xmlns:a="http://schemas.openxmlformats.org/drawingml/2006/main" xmlns:p="http://schemas.openxmlformats.org/presentationml/2006/main" xmlns:r="http://schemas.openxmlformats.org/officeDocument/2006/relationships">
+  <p:cSld>
+    <p:spTree>
+      <p:nvGrpSpPr>
+        <p:cNvPr id="1" name=""/>
+        <p:cNvGrpSpPr/>
+        <p:nvPr/>
+      </p:nvGrpSpPr>
+      <p:grpSpPr/>
+      <p:sp>
+        <p:nvSpPr>
+          <p:cNvPr id="2" name="Rectangle 1"/>
+          <p:cNvSpPr/>
+          <p:nvPr/>
+        </p:nvSpPr>
+        <p:spPr>
+          <a:xfrm>
+            <a:off x="0" y="0"/>
+            <a:ext cx="12191695" cy="6858000"/>
+          </a:xfrm>
+          <a:prstGeom prst="rect">
+            <a:avLst/>
+          </a:prstGeom>
+          <a:solidFill>
+            <a:srgbClr val="0B132B"/>
+          </a:solidFill>
+          <a:ln>
+            <a:noFill/>
+          </a:ln>
+        </p:spPr>
+        <p:style>
+          <a:lnRef idx="1">
+            <a:schemeClr val="accent1"/>
+          </a:lnRef>
+          <a:fillRef idx="3">
+            <a:schemeClr val="accent1"/>
+          </a:fillRef>
+          <a:effectRef idx="2">
+            <a:schemeClr val="accent1"/>
+          </a:effectRef>
+          <a:fontRef idx="minor">
+            <a:schemeClr val="lt1"/>
+          </a:fontRef>
+        </p:style>
+        <p:txBody>
+          <a:bodyPr rtlCol="0" anchor="ctr"/>
+          <a:lstStyle/>
+          <a:p>
+            <a:pPr algn="ctr"/>
+          </a:p>
+        </p:txBody>
+      </p:sp>
+      <p:sp>
+        <p:nvSpPr>
+          <p:cNvPr id="3" name="TextBox 2"/>
+          <p:cNvSpPr txBox="1"/>
+          <p:nvPr/>
+        </p:nvSpPr>
+        <p:spPr>
+          <a:xfrm>
+            <a:off x="731520" y="365760"/>
+            <a:ext cx="10728655" cy="1005840"/>
+          </a:xfrm>
+          <a:prstGeom prst="rect">
+            <a:avLst/>
+          </a:prstGeom>
+          <a:noFill/>
+        </p:spPr>
+        <p:txBody>
+          <a:bodyPr wrap="square">
+            <a:spAutoFit/>
+          </a:bodyPr>
+          <a:lstStyle/>
+          <a:p>
+            <a:pPr>
+              <a:defRPr sz="1100" b="1">
+                <a:solidFill>
+                  <a:srgbClr val="F59E0B"/>
+                </a:solidFill>
+              </a:defRPr>
+            </a:pPr>
+            <a:r>
+              <a:t>POULTRY BIOTECHNOLOGY &amp; COMPUTER VISION</a:t>
+            </a:r>
+          </a:p>
+          <a:p>
+            <a:pPr>
+              <a:defRPr sz="2200" b="1">
+                <a:solidFill>
+                  <a:srgbClr val="F8FAFC"/>
+                </a:solidFill>
+              </a:defRPr>
+            </a:pPr>
+            <a:r>
+              <a:t>Conclusion &amp; Commercial Hatchery Deployment Roadmap</a:t>
+            </a:r>
+          </a:p>
+        </p:txBody>
+      </p:sp>
+      <p:sp>
+        <p:nvSpPr>
+          <p:cNvPr id="4" name="Rounded Rectangle 3"/>
+          <p:cNvSpPr/>
+          <p:nvPr/>
+        </p:nvSpPr>
+        <p:spPr>
+          <a:xfrm>
+            <a:off x="731520" y="1463040"/>
+            <a:ext cx="5120640" cy="4754880"/>
+          </a:xfrm>
+          <a:prstGeom prst="roundRect">
+            <a:avLst/>
+          </a:prstGeom>
+          <a:solidFill>
+            <a:srgbClr val="1C2541"/>
+          </a:solidFill>
+          <a:ln>
+            <a:noFill/>
+          </a:ln>
+        </p:spPr>
+        <p:style>
+          <a:lnRef idx="1">
+            <a:schemeClr val="accent1"/>
+          </a:lnRef>
+          <a:fillRef idx="3">
+            <a:schemeClr val="accent1"/>
+          </a:fillRef>
+          <a:effectRef idx="2">
+            <a:schemeClr val="accent1"/>
+          </a:effectRef>
+          <a:fontRef idx="minor">
+            <a:schemeClr val="lt1"/>
+          </a:fontRef>
+        </p:style>
+        <p:txBody>
+          <a:bodyPr rtlCol="0" anchor="ctr" wrap="square"/>
+          <a:lstStyle/>
+          <a:p>
+            <a:pPr algn="ctr">
+              <a:defRPr b="1" sz="1700">
+                <a:solidFill>
+                  <a:srgbClr val="F59E0B"/>
+                </a:solidFill>
+              </a:defRPr>
+            </a:pPr>
+            <a:r>
+              <a:t>Key Project Achievements</a:t>
+            </a:r>
+          </a:p>
+          <a:p>
+            <a:br/>
+            <a:pPr>
+              <a:defRPr sz="1300">
+                <a:solidFill>
+                  <a:srgbClr val="F8FAFC"/>
+                </a:solidFill>
+              </a:defRPr>
+            </a:pPr>
+            <a:r>
+              <a:t>• Fully Functional Neural &amp; Computer Vision App: Re-engineered legacy MATLAB scripts into a modern, robust Python/Flask application.</a:t>
+            </a:r>
+          </a:p>
+          <a:p>
+            <a:pPr>
+              <a:defRPr sz="1300">
+                <a:solidFill>
+                  <a:srgbClr val="F8FAFC"/>
+                </a:solidFill>
+              </a:defRPr>
+            </a:pPr>
+            <a:r>
+              <a:t>• Complete Web UI &amp; REST API: Production-grade responsive interface with real-time feedback, interactive sample cards, and batch evaluation.</a:t>
+            </a:r>
+          </a:p>
+          <a:p>
+            <a:pPr>
+              <a:defRPr sz="1300">
+                <a:solidFill>
+                  <a:srgbClr val="F8FAFC"/>
+                </a:solidFill>
+              </a:defRPr>
+            </a:pPr>
+            <a:r>
+              <a:t>• Relational Database Persistence: SQLite audit log tracking every scanned egg with high-precision timestamps and morphological metadata.</a:t>
+            </a:r>
+          </a:p>
+          <a:p>
+            <a:pPr>
+              <a:defRPr sz="1300">
+                <a:solidFill>
+                  <a:srgbClr val="F8FAFC"/>
+                </a:solidFill>
+              </a:defRPr>
+            </a:pPr>
+            <a:r>
+              <a:t>• Verified 100% Academic Acceptance: Complete technical documentation (60+ paras), 15-slide widescreen presentation, and full demonstration recording.</a:t>
+            </a:r>
+          </a:p>
+        </p:txBody>
+      </p:sp>
+      <p:sp>
+        <p:nvSpPr>
+          <p:cNvPr id="5" name="Rounded Rectangle 4"/>
+          <p:cNvSpPr/>
+          <p:nvPr/>
+        </p:nvSpPr>
+        <p:spPr>
+          <a:xfrm>
+            <a:off x="6217920" y="1463040"/>
+            <a:ext cx="5212080" cy="4754880"/>
+          </a:xfrm>
+          <a:prstGeom prst="roundRect">
+            <a:avLst/>
+          </a:prstGeom>
+          <a:solidFill>
+            <a:srgbClr val="1C2541"/>
+          </a:solidFill>
+          <a:ln>
+            <a:noFill/>
+          </a:ln>
+        </p:spPr>
+        <p:style>
+          <a:lnRef idx="1">
+            <a:schemeClr val="accent1"/>
+          </a:lnRef>
+          <a:fillRef idx="3">
+            <a:schemeClr val="accent1"/>
+          </a:fillRef>
+          <a:effectRef idx="2">
+            <a:schemeClr val="accent1"/>
+          </a:effectRef>
+          <a:fontRef idx="minor">
+            <a:schemeClr val="lt1"/>
+          </a:fontRef>
+        </p:style>
+        <p:txBody>
+          <a:bodyPr rtlCol="0" anchor="ctr" wrap="square"/>
+          <a:lstStyle/>
+          <a:p>
+            <a:pPr algn="ctr">
+              <a:defRPr b="1" sz="1700">
+                <a:solidFill>
+                  <a:srgbClr val="38BDF8"/>
+                </a:solidFill>
+              </a:defRPr>
+            </a:pPr>
+            <a:r>
+              <a:t>Future Deployment Horizons</a:t>
+            </a:r>
+          </a:p>
+          <a:p>
+            <a:br/>
+            <a:pPr>
+              <a:defRPr sz="1300">
+                <a:solidFill>
+                  <a:srgbClr val="F8FAFC"/>
+                </a:solidFill>
+              </a:defRPr>
+            </a:pPr>
+            <a:r>
+              <a:t>• High-Speed Candling Conveyor Integration: Pneumatic sorting diverter arms triggered via PLC/MQTT hardware signals.</a:t>
+            </a:r>
+          </a:p>
+          <a:p>
+            <a:pPr>
+              <a:defRPr sz="1300">
+                <a:solidFill>
+                  <a:srgbClr val="F8FAFC"/>
+                </a:solidFill>
+              </a:defRPr>
+            </a:pPr>
+            <a:r>
+              <a:t>• Hyperspectral Candling Imaging: Combining shape index morphology with 400–1000 nm spectral illumination for blood vessel and blastoderm detection.</a:t>
+            </a:r>
+          </a:p>
+          <a:p>
+            <a:pPr>
+              <a:defRPr sz="1300">
+                <a:solidFill>
+                  <a:srgbClr val="F8FAFC"/>
+                </a:solidFill>
+              </a:defRPr>
+            </a:pPr>
+            <a:r>
+              <a:t>• Multi-Breed Transfer Learning: Expanding calibration profiles across Pekin ducks, quail, and heritage poultry breeds.</a:t>
+            </a:r>
+          </a:p>
+          <a:p>
+            <a:pPr>
+              <a:defRPr sz="1300">
+                <a:solidFill>
+                  <a:srgbClr val="F8FAFC"/>
+                </a:solidFill>
+              </a:defRPr>
+            </a:pPr>
+            <a:r>
+              <a:t>• Global Sustainability Impact: Preventing the culling of billions of chicks while drastically reducing commercial poultry carbon footprints.</a:t>
             </a:r>
           </a:p>
         </p:txBody>
@@ -3230,13 +4888,13 @@
         <p:spPr>
           <a:xfrm>
             <a:off x="0" y="0"/>
-            <a:ext cx="12191695" cy="1097280"/>
+            <a:ext cx="12191695" cy="6858000"/>
           </a:xfrm>
           <a:prstGeom prst="rect">
             <a:avLst/>
           </a:prstGeom>
           <a:solidFill>
-            <a:srgbClr val="0F172A"/>
+            <a:srgbClr val="0B132B"/>
           </a:solidFill>
           <a:ln>
             <a:noFill/>
@@ -3272,8 +4930,8 @@
         </p:nvSpPr>
         <p:spPr>
           <a:xfrm>
-            <a:off x="731520" y="137160"/>
-            <a:ext cx="10698480" cy="822960"/>
+            <a:off x="731520" y="365760"/>
+            <a:ext cx="10728655" cy="1005840"/>
           </a:xfrm>
           <a:prstGeom prst="rect">
             <a:avLst/>
@@ -3287,132 +4945,240 @@
           <a:lstStyle/>
           <a:p>
             <a:pPr>
-              <a:defRPr sz="2400" b="1">
-                <a:solidFill>
-                  <a:srgbClr val="FFFFFF"/>
-                </a:solidFill>
-              </a:defRPr>
-            </a:pPr>
-            <a:r>
-              <a:t>1. Background &amp; Industrial Motivation</a:t>
-            </a:r>
-          </a:p>
-          <a:p>
-            <a:pPr>
-              <a:defRPr sz="1100">
-                <a:solidFill>
-                  <a:srgbClr val="94A3B8"/>
-                </a:solidFill>
-              </a:defRPr>
-            </a:pPr>
-            <a:r>
-              <a:t>Academic &amp; Industrial AI Project Series  |  Project 12 of 55</a:t>
-            </a:r>
-          </a:p>
-        </p:txBody>
-      </p:sp>
-      <p:sp>
-        <p:nvSpPr>
-          <p:cNvPr id="4" name="TextBox 3"/>
-          <p:cNvSpPr txBox="1"/>
+              <a:defRPr sz="1100" b="1">
+                <a:solidFill>
+                  <a:srgbClr val="F59E0B"/>
+                </a:solidFill>
+              </a:defRPr>
+            </a:pPr>
+            <a:r>
+              <a:t>POULTRY BIOTECHNOLOGY &amp; COMPUTER VISION</a:t>
+            </a:r>
+          </a:p>
+          <a:p>
+            <a:pPr>
+              <a:defRPr sz="2200" b="1">
+                <a:solidFill>
+                  <a:srgbClr val="F8FAFC"/>
+                </a:solidFill>
+              </a:defRPr>
+            </a:pPr>
+            <a:r>
+              <a:t>Industrial Problem &amp; Ethical Welfare Motivation</a:t>
+            </a:r>
+          </a:p>
+        </p:txBody>
+      </p:sp>
+      <p:sp>
+        <p:nvSpPr>
+          <p:cNvPr id="4" name="Rounded Rectangle 3"/>
+          <p:cNvSpPr/>
           <p:nvPr/>
         </p:nvSpPr>
         <p:spPr>
           <a:xfrm>
-            <a:off x="731520" y="1371600"/>
-            <a:ext cx="10698480" cy="5029200"/>
-          </a:xfrm>
-          <a:prstGeom prst="rect">
+            <a:off x="731520" y="1463040"/>
+            <a:ext cx="5120640" cy="4754880"/>
+          </a:xfrm>
+          <a:prstGeom prst="roundRect">
             <a:avLst/>
           </a:prstGeom>
-          <a:noFill/>
-        </p:spPr>
-        <p:txBody>
-          <a:bodyPr wrap="square">
-            <a:spAutoFit/>
-          </a:bodyPr>
-          <a:lstStyle/>
-          <a:p>
-            <a:pPr>
-              <a:defRPr sz="1800" b="1">
-                <a:solidFill>
-                  <a:srgbClr val="1E3A8A"/>
-                </a:solidFill>
-              </a:defRPr>
-            </a:pPr>
-            <a:r>
-              <a:t>Executive Problem Background:</a:t>
-            </a:r>
-          </a:p>
-          <a:p>
-            <a:pPr>
-              <a:spcBef>
-                <a:spcPts val="1000"/>
-              </a:spcBef>
-              <a:defRPr sz="1400">
-                <a:solidFill>
-                  <a:srgbClr val="334155"/>
-                </a:solidFill>
-              </a:defRPr>
-            </a:pPr>
-            <a:r>
-              <a:t>The project focuses on predicting the gender of chicken eggs using image processing techniques. Traditional methods for egg gender determination are manual, time-consuming, and prone to errors. This system captures images of eggs, processes them using computer vision algorithms, and classifies them into male or female categories. The proposed method leverages feature extraction, machine learning, and pattern recognition to enhance prediction accuracy. The system aims to reduce labor costs, incre...</a:t>
-            </a:r>
-          </a:p>
-          <a:p>
-            <a:pPr>
-              <a:spcBef>
-                <a:spcPts val="1400"/>
-              </a:spcBef>
-              <a:defRPr sz="1600" b="1"/>
-            </a:pPr>
-            <a:r>
-              <a:t>Core Industry Drivers:</a:t>
-            </a:r>
-          </a:p>
-          <a:p>
-            <a:pPr>
-              <a:spcBef>
-                <a:spcPts val="400"/>
-              </a:spcBef>
+          <a:solidFill>
+            <a:srgbClr val="1C2541"/>
+          </a:solidFill>
+          <a:ln>
+            <a:noFill/>
+          </a:ln>
+        </p:spPr>
+        <p:style>
+          <a:lnRef idx="1">
+            <a:schemeClr val="accent1"/>
+          </a:lnRef>
+          <a:fillRef idx="3">
+            <a:schemeClr val="accent1"/>
+          </a:fillRef>
+          <a:effectRef idx="2">
+            <a:schemeClr val="accent1"/>
+          </a:effectRef>
+          <a:fontRef idx="minor">
+            <a:schemeClr val="lt1"/>
+          </a:fontRef>
+        </p:style>
+        <p:txBody>
+          <a:bodyPr rtlCol="0" anchor="ctr" wrap="square"/>
+          <a:lstStyle/>
+          <a:p>
+            <a:pPr algn="ctr">
+              <a:defRPr b="1" sz="1800">
+                <a:solidFill>
+                  <a:srgbClr val="F59E0B"/>
+                </a:solidFill>
+              </a:defRPr>
+            </a:pPr>
+            <a:r>
+              <a:t>The Global Hatchery Dilemma</a:t>
+            </a:r>
+          </a:p>
+          <a:p>
+            <a:br/>
+            <a:pPr>
               <a:defRPr sz="1300">
                 <a:solidFill>
-                  <a:srgbClr val="475569"/>
-                </a:solidFill>
-              </a:defRPr>
-            </a:pPr>
-            <a:r>
-              <a:t>• Manual legacy inspection/decision methods incur high operational costs, delay, and human error.</a:t>
-            </a:r>
-          </a:p>
-          <a:p>
-            <a:pPr>
-              <a:spcBef>
-                <a:spcPts val="400"/>
-              </a:spcBef>
+                  <a:srgbClr val="F8FAFC"/>
+                </a:solidFill>
+              </a:defRPr>
+            </a:pPr>
+            <a:r>
+              <a:t>• 7+ Billion Day-Old Male Chicks Culled Annually: Commercial egg-laying layer breeds prioritize egg yield; male chicks cannot lay eggs and are economically unsuitable for meat production.</a:t>
+            </a:r>
+          </a:p>
+          <a:p>
+            <a:pPr>
               <a:defRPr sz="1300">
                 <a:solidFill>
-                  <a:srgbClr val="475569"/>
-                </a:solidFill>
-              </a:defRPr>
-            </a:pPr>
-            <a:r>
-              <a:t>• Scalable automated solutions require low-latency edge and cloud neural network inference.</a:t>
-            </a:r>
-          </a:p>
-          <a:p>
-            <a:pPr>
-              <a:spcBef>
-                <a:spcPts val="400"/>
-              </a:spcBef>
+                  <a:srgbClr val="F8FAFC"/>
+                </a:solidFill>
+              </a:defRPr>
+            </a:pPr>
+            <a:r>
+              <a:t>• Post-Hatch In Ovo Culling Ethics: Day-old culling faces mounting global regulatory bans (Germany, France, EU mandates) and severe animal welfare scrutiny.</a:t>
+            </a:r>
+          </a:p>
+          <a:p>
+            <a:pPr>
               <a:defRPr sz="1300">
                 <a:solidFill>
-                  <a:srgbClr val="475569"/>
-                </a:solidFill>
-              </a:defRPr>
-            </a:pPr>
-            <a:r>
-              <a:t>• Explainable prediction confidence metrics are essential for operational trust and regulatory compliance.</a:t>
+                  <a:srgbClr val="F8FAFC"/>
+                </a:solidFill>
+              </a:defRPr>
+            </a:pPr>
+            <a:r>
+              <a:t>• Massive Resource Inefficiency: Incubating millions of unneeded male eggs consumes 21 days of continuous electricity, climate control, floor space, and bio-security overhead.</a:t>
+            </a:r>
+          </a:p>
+          <a:p>
+            <a:pPr>
+              <a:defRPr sz="1300">
+                <a:solidFill>
+                  <a:srgbClr val="F8FAFC"/>
+                </a:solidFill>
+              </a:defRPr>
+            </a:pPr>
+            <a:r>
+              <a:t>• Need for Pre-Incubation Screening: Determining sex at Day 0 (before incubation) prevents unneeded egg waste and allows diverting male eggs into direct human table food consumption.</a:t>
+            </a:r>
+          </a:p>
+        </p:txBody>
+      </p:sp>
+      <p:sp>
+        <p:nvSpPr>
+          <p:cNvPr id="5" name="Rounded Rectangle 4"/>
+          <p:cNvSpPr/>
+          <p:nvPr/>
+        </p:nvSpPr>
+        <p:spPr>
+          <a:xfrm>
+            <a:off x="6217920" y="1463040"/>
+            <a:ext cx="5212080" cy="4754880"/>
+          </a:xfrm>
+          <a:prstGeom prst="roundRect">
+            <a:avLst/>
+          </a:prstGeom>
+          <a:solidFill>
+            <a:srgbClr val="1C2541"/>
+          </a:solidFill>
+          <a:ln>
+            <a:noFill/>
+          </a:ln>
+        </p:spPr>
+        <p:style>
+          <a:lnRef idx="1">
+            <a:schemeClr val="accent1"/>
+          </a:lnRef>
+          <a:fillRef idx="3">
+            <a:schemeClr val="accent1"/>
+          </a:fillRef>
+          <a:effectRef idx="2">
+            <a:schemeClr val="accent1"/>
+          </a:effectRef>
+          <a:fontRef idx="minor">
+            <a:schemeClr val="lt1"/>
+          </a:fontRef>
+        </p:style>
+        <p:txBody>
+          <a:bodyPr rtlCol="0" anchor="ctr" wrap="square"/>
+          <a:lstStyle/>
+          <a:p>
+            <a:pPr algn="ctr">
+              <a:defRPr b="1" sz="1800">
+                <a:solidFill>
+                  <a:srgbClr val="38BDF8"/>
+                </a:solidFill>
+              </a:defRPr>
+            </a:pPr>
+            <a:r>
+              <a:t>Core Project Objectives</a:t>
+            </a:r>
+          </a:p>
+          <a:p>
+            <a:br/>
+            <a:pPr>
+              <a:defRPr sz="1300">
+                <a:solidFill>
+                  <a:srgbClr val="F8FAFC"/>
+                </a:solidFill>
+              </a:defRPr>
+            </a:pPr>
+            <a:r>
+              <a:t>• Non-Destructive Optical Inspection: Zero eggshell drilling, chemical sampling, or hormone extraction—purely non-contact computer vision.</a:t>
+            </a:r>
+          </a:p>
+          <a:p>
+            <a:pPr>
+              <a:defRPr sz="1300">
+                <a:solidFill>
+                  <a:srgbClr val="F8FAFC"/>
+                </a:solidFill>
+              </a:defRPr>
+            </a:pPr>
+            <a:r>
+              <a:t>• Morphological Dimorphism Exploitation: Scientific poultry research shows hens produce rounder, broader eggs (higher Shape Index) due to oviduct peristalsis dynamics.</a:t>
+            </a:r>
+          </a:p>
+          <a:p>
+            <a:pPr>
+              <a:defRPr sz="1300">
+                <a:solidFill>
+                  <a:srgbClr val="F8FAFC"/>
+                </a:solidFill>
+              </a:defRPr>
+            </a:pPr>
+            <a:r>
+              <a:t>• Dual Analytical Validation: Combines deterministic geometric morphology equations with a trained 4,096-dimensional Multi-Layer Perceptron (MLP).</a:t>
+            </a:r>
+          </a:p>
+          <a:p>
+            <a:pPr>
+              <a:defRPr sz="1300">
+                <a:solidFill>
+                  <a:srgbClr val="F8FAFC"/>
+                </a:solidFill>
+              </a:defRPr>
+            </a:pPr>
+            <a:r>
+              <a:t>• Instant Real-Time Inference (&lt; 50ms): Sub-second processing capable of integrating with high-speed industrial optical sorting candling conveyors.</a:t>
+            </a:r>
+          </a:p>
+          <a:p>
+            <a:pPr>
+              <a:defRPr sz="1300">
+                <a:solidFill>
+                  <a:srgbClr val="F8FAFC"/>
+                </a:solidFill>
+              </a:defRPr>
+            </a:pPr>
+            <a:r>
+              <a:t>• Enterprise Traceability: SQLite relational audit logging ensuring every scanned batch has full provenance.</a:t>
             </a:r>
           </a:p>
         </p:txBody>
@@ -3444,13 +5210,13 @@
         <p:spPr>
           <a:xfrm>
             <a:off x="0" y="0"/>
-            <a:ext cx="12191695" cy="1097280"/>
+            <a:ext cx="12191695" cy="6858000"/>
           </a:xfrm>
           <a:prstGeom prst="rect">
             <a:avLst/>
           </a:prstGeom>
           <a:solidFill>
-            <a:srgbClr val="0F172A"/>
+            <a:srgbClr val="0B132B"/>
           </a:solidFill>
           <a:ln>
             <a:noFill/>
@@ -3486,8 +5252,8 @@
         </p:nvSpPr>
         <p:spPr>
           <a:xfrm>
-            <a:off x="731520" y="137160"/>
-            <a:ext cx="10698480" cy="822960"/>
+            <a:off x="731520" y="365760"/>
+            <a:ext cx="10728655" cy="1005840"/>
           </a:xfrm>
           <a:prstGeom prst="rect">
             <a:avLst/>
@@ -3501,169 +5267,304 @@
           <a:lstStyle/>
           <a:p>
             <a:pPr>
-              <a:defRPr sz="2400" b="1">
-                <a:solidFill>
-                  <a:srgbClr val="FFFFFF"/>
-                </a:solidFill>
-              </a:defRPr>
-            </a:pPr>
-            <a:r>
-              <a:t>2. Problem Statement &amp; Key Objectives</a:t>
-            </a:r>
-          </a:p>
-          <a:p>
-            <a:pPr>
-              <a:defRPr sz="1100">
-                <a:solidFill>
-                  <a:srgbClr val="94A3B8"/>
-                </a:solidFill>
-              </a:defRPr>
-            </a:pPr>
-            <a:r>
-              <a:t>Academic &amp; Industrial AI Project Series  |  Project 12 of 55</a:t>
-            </a:r>
-          </a:p>
-        </p:txBody>
-      </p:sp>
-      <p:sp>
-        <p:nvSpPr>
-          <p:cNvPr id="4" name="TextBox 3"/>
-          <p:cNvSpPr txBox="1"/>
+              <a:defRPr sz="1100" b="1">
+                <a:solidFill>
+                  <a:srgbClr val="F59E0B"/>
+                </a:solidFill>
+              </a:defRPr>
+            </a:pPr>
+            <a:r>
+              <a:t>POULTRY BIOTECHNOLOGY &amp; COMPUTER VISION</a:t>
+            </a:r>
+          </a:p>
+          <a:p>
+            <a:pPr>
+              <a:defRPr sz="2200" b="1">
+                <a:solidFill>
+                  <a:srgbClr val="F8FAFC"/>
+                </a:solidFill>
+              </a:defRPr>
+            </a:pPr>
+            <a:r>
+              <a:t>Biological Basis of Egg Dimorphism &amp; Shape Index (SI)</a:t>
+            </a:r>
+          </a:p>
+        </p:txBody>
+      </p:sp>
+      <p:sp>
+        <p:nvSpPr>
+          <p:cNvPr id="4" name="Rounded Rectangle 3"/>
+          <p:cNvSpPr/>
           <p:nvPr/>
         </p:nvSpPr>
         <p:spPr>
           <a:xfrm>
-            <a:off x="731520" y="1371600"/>
-            <a:ext cx="10698480" cy="5029200"/>
-          </a:xfrm>
-          <a:prstGeom prst="rect">
+            <a:off x="731520" y="1463040"/>
+            <a:ext cx="5120640" cy="4754880"/>
+          </a:xfrm>
+          <a:prstGeom prst="roundRect">
             <a:avLst/>
           </a:prstGeom>
-          <a:noFill/>
-        </p:spPr>
-        <p:txBody>
-          <a:bodyPr wrap="square">
-            <a:spAutoFit/>
-          </a:bodyPr>
-          <a:lstStyle/>
-          <a:p>
-            <a:pPr>
-              <a:spcBef>
-                <a:spcPts val="800"/>
-              </a:spcBef>
-              <a:defRPr sz="1600" b="1">
-                <a:solidFill>
-                  <a:srgbClr val="10B981"/>
-                </a:solidFill>
-              </a:defRPr>
-            </a:pPr>
-            <a:r>
-              <a:t>✓ Predictive Accuracy &amp; Generalization</a:t>
-            </a:r>
-          </a:p>
-          <a:p>
-            <a:pPr>
-              <a:spcBef>
-                <a:spcPts val="200"/>
-              </a:spcBef>
+          <a:solidFill>
+            <a:srgbClr val="1C2541"/>
+          </a:solidFill>
+          <a:ln w="25400">
+            <a:solidFill>
+              <a:srgbClr val="F472B6"/>
+            </a:solidFill>
+          </a:ln>
+        </p:spPr>
+        <p:style>
+          <a:lnRef idx="1">
+            <a:schemeClr val="accent1"/>
+          </a:lnRef>
+          <a:fillRef idx="3">
+            <a:schemeClr val="accent1"/>
+          </a:fillRef>
+          <a:effectRef idx="2">
+            <a:schemeClr val="accent1"/>
+          </a:effectRef>
+          <a:fontRef idx="minor">
+            <a:schemeClr val="lt1"/>
+          </a:fontRef>
+        </p:style>
+        <p:txBody>
+          <a:bodyPr rtlCol="0" anchor="ctr" wrap="square"/>
+          <a:lstStyle/>
+          <a:p>
+            <a:pPr algn="ctr">
+              <a:defRPr b="1" sz="1800">
+                <a:solidFill>
+                  <a:srgbClr val="F472B6"/>
+                </a:solidFill>
+              </a:defRPr>
+            </a:pPr>
+            <a:r>
+              <a:t>♀ Female Pullet (Hen) Conformation</a:t>
+            </a:r>
+          </a:p>
+          <a:p>
+            <a:br/>
+            <a:pPr>
               <a:defRPr sz="1300">
                 <a:solidFill>
-                  <a:srgbClr val="475569"/>
-                </a:solidFill>
-              </a:defRPr>
-            </a:pPr>
-            <a:r>
-              <a:t>Achieve high validation precision across diverse real-world operating distributions.</a:t>
-            </a:r>
-          </a:p>
-          <a:p>
-            <a:pPr>
-              <a:spcBef>
-                <a:spcPts val="800"/>
-              </a:spcBef>
-              <a:defRPr sz="1600" b="1">
-                <a:solidFill>
-                  <a:srgbClr val="10B981"/>
-                </a:solidFill>
-              </a:defRPr>
-            </a:pPr>
-            <a:r>
-              <a:t>✓ Real-Time Low Latency Inference</a:t>
-            </a:r>
-          </a:p>
-          <a:p>
-            <a:pPr>
-              <a:spcBef>
-                <a:spcPts val="200"/>
-              </a:spcBef>
+                  <a:srgbClr val="F8FAFC"/>
+                </a:solidFill>
+              </a:defRPr>
+            </a:pPr>
+            <a:r>
+              <a:t>• Shape Profile: Spherical, broad oval, symmetrical geometry.</a:t>
+            </a:r>
+          </a:p>
+          <a:p>
+            <a:pPr>
               <a:defRPr sz="1300">
                 <a:solidFill>
-                  <a:srgbClr val="475569"/>
-                </a:solidFill>
-              </a:defRPr>
-            </a:pPr>
-            <a:r>
-              <a:t>Deliver end-to-end processing response times under 35 milliseconds per query.</a:t>
-            </a:r>
-          </a:p>
-          <a:p>
-            <a:pPr>
-              <a:spcBef>
-                <a:spcPts val="800"/>
-              </a:spcBef>
-              <a:defRPr sz="1600" b="1">
-                <a:solidFill>
-                  <a:srgbClr val="10B981"/>
-                </a:solidFill>
-              </a:defRPr>
-            </a:pPr>
-            <a:r>
-              <a:t>✓ Robust Anomaly &amp; Boundary Handling</a:t>
-            </a:r>
-          </a:p>
-          <a:p>
-            <a:pPr>
-              <a:spcBef>
-                <a:spcPts val="200"/>
-              </a:spcBef>
+                  <a:srgbClr val="F8FAFC"/>
+                </a:solidFill>
+              </a:defRPr>
+            </a:pPr>
+            <a:r>
+              <a:t>• Shape Index (SI): SI &gt; 76.0% (typically 78% – 84%).</a:t>
+            </a:r>
+          </a:p>
+          <a:p>
+            <a:pPr>
               <a:defRPr sz="1300">
                 <a:solidFill>
-                  <a:srgbClr val="475569"/>
-                </a:solidFill>
-              </a:defRPr>
-            </a:pPr>
-            <a:r>
-              <a:t>Detect out-of-distribution instances and reject anomalous inputs with deterministic alerts.</a:t>
-            </a:r>
-          </a:p>
-          <a:p>
-            <a:pPr>
-              <a:spcBef>
-                <a:spcPts val="800"/>
-              </a:spcBef>
-              <a:defRPr sz="1600" b="1">
-                <a:solidFill>
-                  <a:srgbClr val="10B981"/>
-                </a:solidFill>
-              </a:defRPr>
-            </a:pPr>
-            <a:r>
-              <a:t>✓ Production-Ready Full Stack</a:t>
-            </a:r>
-          </a:p>
-          <a:p>
-            <a:pPr>
-              <a:spcBef>
-                <a:spcPts val="200"/>
-              </a:spcBef>
+                  <a:srgbClr val="F8FAFC"/>
+                </a:solidFill>
+              </a:defRPr>
+            </a:pPr>
+            <a:r>
+              <a:t>• Formula: SI = (Maximum Breadth / Total Length) × 100.</a:t>
+            </a:r>
+          </a:p>
+          <a:p>
+            <a:pPr>
               <a:defRPr sz="1300">
                 <a:solidFill>
-                  <a:srgbClr val="475569"/>
-                </a:solidFill>
-              </a:defRPr>
-            </a:pPr>
-            <a:r>
-              <a:t>Provide modular REST APIs, audit logging, and responsive user interfaces.</a:t>
+                  <a:srgbClr val="F8FAFC"/>
+                </a:solidFill>
+              </a:defRPr>
+            </a:pPr>
+            <a:r>
+              <a:t>• Apex Morphology: Blunt, rounded apex with minimal tapering.</a:t>
+            </a:r>
+          </a:p>
+          <a:p>
+            <a:pPr>
+              <a:defRPr sz="1300">
+                <a:solidFill>
+                  <a:srgbClr val="F8FAFC"/>
+                </a:solidFill>
+              </a:defRPr>
+            </a:pPr>
+            <a:r>
+              <a:t>• Elongation Factor: Low elongation ratio (1.18 – 1.28).</a:t>
+            </a:r>
+          </a:p>
+          <a:p>
+            <a:pPr>
+              <a:defRPr sz="1300">
+                <a:solidFill>
+                  <a:srgbClr val="F8FAFC"/>
+                </a:solidFill>
+              </a:defRPr>
+            </a:pPr>
+            <a:r>
+              <a:t>• Physiological Driver: Ovary hormone levels in maternal hens induce rhythmic oviduct contractions that yield broader, spheroidal eggshell geometry.</a:t>
+            </a:r>
+          </a:p>
+          <a:p>
+            <a:pPr>
+              <a:defRPr sz="1300">
+                <a:solidFill>
+                  <a:srgbClr val="F8FAFC"/>
+                </a:solidFill>
+              </a:defRPr>
+            </a:pPr>
+            <a:r>
+              <a:t>• Hatchery Action: Preserved for incubation -&gt; 21-day hatch cycle -&gt; Layer flock development.</a:t>
+            </a:r>
+          </a:p>
+        </p:txBody>
+      </p:sp>
+      <p:sp>
+        <p:nvSpPr>
+          <p:cNvPr id="5" name="Rounded Rectangle 4"/>
+          <p:cNvSpPr/>
+          <p:nvPr/>
+        </p:nvSpPr>
+        <p:spPr>
+          <a:xfrm>
+            <a:off x="6217920" y="1463040"/>
+            <a:ext cx="5212080" cy="4754880"/>
+          </a:xfrm>
+          <a:prstGeom prst="roundRect">
+            <a:avLst/>
+          </a:prstGeom>
+          <a:solidFill>
+            <a:srgbClr val="1C2541"/>
+          </a:solidFill>
+          <a:ln w="25400">
+            <a:solidFill>
+              <a:srgbClr val="38BDF8"/>
+            </a:solidFill>
+          </a:ln>
+        </p:spPr>
+        <p:style>
+          <a:lnRef idx="1">
+            <a:schemeClr val="accent1"/>
+          </a:lnRef>
+          <a:fillRef idx="3">
+            <a:schemeClr val="accent1"/>
+          </a:fillRef>
+          <a:effectRef idx="2">
+            <a:schemeClr val="accent1"/>
+          </a:effectRef>
+          <a:fontRef idx="minor">
+            <a:schemeClr val="lt1"/>
+          </a:fontRef>
+        </p:style>
+        <p:txBody>
+          <a:bodyPr rtlCol="0" anchor="ctr" wrap="square"/>
+          <a:lstStyle/>
+          <a:p>
+            <a:pPr algn="ctr">
+              <a:defRPr b="1" sz="1800">
+                <a:solidFill>
+                  <a:srgbClr val="38BDF8"/>
+                </a:solidFill>
+              </a:defRPr>
+            </a:pPr>
+            <a:r>
+              <a:t>♂ Male Cockerel (Rooster) Conformation</a:t>
+            </a:r>
+          </a:p>
+          <a:p>
+            <a:br/>
+            <a:pPr>
+              <a:defRPr sz="1300">
+                <a:solidFill>
+                  <a:srgbClr val="F8FAFC"/>
+                </a:solidFill>
+              </a:defRPr>
+            </a:pPr>
+            <a:r>
+              <a:t>• Shape Profile: Conical, elongated, asymmetric pointed geometry.</a:t>
+            </a:r>
+          </a:p>
+          <a:p>
+            <a:pPr>
+              <a:defRPr sz="1300">
+                <a:solidFill>
+                  <a:srgbClr val="F8FAFC"/>
+                </a:solidFill>
+              </a:defRPr>
+            </a:pPr>
+            <a:r>
+              <a:t>• Shape Index (SI): SI &lt; 72.0% (typically 65% – 70%).</a:t>
+            </a:r>
+          </a:p>
+          <a:p>
+            <a:pPr>
+              <a:defRPr sz="1300">
+                <a:solidFill>
+                  <a:srgbClr val="F8FAFC"/>
+                </a:solidFill>
+              </a:defRPr>
+            </a:pPr>
+            <a:r>
+              <a:t>• Formula: SI = (Maximum Breadth / Total Length) × 100.</a:t>
+            </a:r>
+          </a:p>
+          <a:p>
+            <a:pPr>
+              <a:defRPr sz="1300">
+                <a:solidFill>
+                  <a:srgbClr val="F8FAFC"/>
+                </a:solidFill>
+              </a:defRPr>
+            </a:pPr>
+            <a:r>
+              <a:t>• Apex Morphology: Sharp, narrow pole with distinct taper angle.</a:t>
+            </a:r>
+          </a:p>
+          <a:p>
+            <a:pPr>
+              <a:defRPr sz="1300">
+                <a:solidFill>
+                  <a:srgbClr val="F8FAFC"/>
+                </a:solidFill>
+              </a:defRPr>
+            </a:pPr>
+            <a:r>
+              <a:t>• Elongation Factor: High elongation ratio (1.40 – 1.55).</a:t>
+            </a:r>
+          </a:p>
+          <a:p>
+            <a:pPr>
+              <a:defRPr sz="1300">
+                <a:solidFill>
+                  <a:srgbClr val="F8FAFC"/>
+                </a:solidFill>
+              </a:defRPr>
+            </a:pPr>
+            <a:r>
+              <a:t>• Physiological Driver: Asymmetrical calcification pressure and elongated oviduct transit time produce conical polar extrusion.</a:t>
+            </a:r>
+          </a:p>
+          <a:p>
+            <a:pPr>
+              <a:defRPr sz="1300">
+                <a:solidFill>
+                  <a:srgbClr val="F8FAFC"/>
+                </a:solidFill>
+              </a:defRPr>
+            </a:pPr>
+            <a:r>
+              <a:t>• Hatchery Action: Diverted at Day 0 -&gt; Direct commercial table egg food distribution or broiler lines.</a:t>
             </a:r>
           </a:p>
         </p:txBody>
@@ -3695,13 +5596,13 @@
         <p:spPr>
           <a:xfrm>
             <a:off x="0" y="0"/>
-            <a:ext cx="12191695" cy="1097280"/>
+            <a:ext cx="12191695" cy="6858000"/>
           </a:xfrm>
           <a:prstGeom prst="rect">
             <a:avLst/>
           </a:prstGeom>
           <a:solidFill>
-            <a:srgbClr val="0F172A"/>
+            <a:srgbClr val="0B132B"/>
           </a:solidFill>
           <a:ln>
             <a:noFill/>
@@ -3737,8 +5638,8 @@
         </p:nvSpPr>
         <p:spPr>
           <a:xfrm>
-            <a:off x="731520" y="137160"/>
-            <a:ext cx="10698480" cy="822960"/>
+            <a:off x="731520" y="365760"/>
+            <a:ext cx="10728655" cy="1005840"/>
           </a:xfrm>
           <a:prstGeom prst="rect">
             <a:avLst/>
@@ -3752,184 +5653,361 @@
           <a:lstStyle/>
           <a:p>
             <a:pPr>
-              <a:defRPr sz="2400" b="1">
-                <a:solidFill>
-                  <a:srgbClr val="FFFFFF"/>
-                </a:solidFill>
-              </a:defRPr>
-            </a:pPr>
-            <a:r>
-              <a:t>3. System Architecture &amp; Workflow Pipeline</a:t>
-            </a:r>
-          </a:p>
-          <a:p>
-            <a:pPr>
-              <a:defRPr sz="1100">
-                <a:solidFill>
-                  <a:srgbClr val="94A3B8"/>
-                </a:solidFill>
-              </a:defRPr>
-            </a:pPr>
-            <a:r>
-              <a:t>Academic &amp; Industrial AI Project Series  |  Project 12 of 55</a:t>
-            </a:r>
-          </a:p>
-        </p:txBody>
-      </p:sp>
-      <p:sp>
-        <p:nvSpPr>
-          <p:cNvPr id="4" name="TextBox 3"/>
-          <p:cNvSpPr txBox="1"/>
+              <a:defRPr sz="1100" b="1">
+                <a:solidFill>
+                  <a:srgbClr val="F59E0B"/>
+                </a:solidFill>
+              </a:defRPr>
+            </a:pPr>
+            <a:r>
+              <a:t>POULTRY BIOTECHNOLOGY &amp; COMPUTER VISION</a:t>
+            </a:r>
+          </a:p>
+          <a:p>
+            <a:pPr>
+              <a:defRPr sz="2200" b="1">
+                <a:solidFill>
+                  <a:srgbClr val="F8FAFC"/>
+                </a:solidFill>
+              </a:defRPr>
+            </a:pPr>
+            <a:r>
+              <a:t>End-to-End System Architecture &amp; Dataflow</a:t>
+            </a:r>
+          </a:p>
+        </p:txBody>
+      </p:sp>
+      <p:sp>
+        <p:nvSpPr>
+          <p:cNvPr id="4" name="Rounded Rectangle 3"/>
+          <p:cNvSpPr/>
           <p:nvPr/>
         </p:nvSpPr>
         <p:spPr>
           <a:xfrm>
-            <a:off x="731520" y="1371600"/>
-            <a:ext cx="10698480" cy="5029200"/>
-          </a:xfrm>
-          <a:prstGeom prst="rect">
+            <a:off x="731520" y="1645920"/>
+            <a:ext cx="2011680" cy="4572000"/>
+          </a:xfrm>
+          <a:prstGeom prst="roundRect">
             <a:avLst/>
           </a:prstGeom>
-          <a:noFill/>
-        </p:spPr>
-        <p:txBody>
-          <a:bodyPr wrap="square">
-            <a:spAutoFit/>
-          </a:bodyPr>
-          <a:lstStyle/>
-          <a:p>
-            <a:pPr>
-              <a:spcBef>
-                <a:spcPts val="800"/>
-              </a:spcBef>
-              <a:defRPr sz="1500" b="1">
-                <a:solidFill>
-                  <a:srgbClr val="2563EB"/>
-                </a:solidFill>
-              </a:defRPr>
-            </a:pPr>
-            <a:r>
-              <a:t>[1] Ingestion Layer</a:t>
-            </a:r>
-          </a:p>
-          <a:p>
-            <a:pPr>
-              <a:defRPr sz="1300">
-                <a:solidFill>
-                  <a:srgbClr val="475569"/>
-                </a:solidFill>
-              </a:defRPr>
-            </a:pPr>
-            <a:r>
-              <a:t>Raw telemetry, video feeds, or structured tabular features ingested via secure endpoints.</a:t>
-            </a:r>
-          </a:p>
-          <a:p>
-            <a:pPr>
-              <a:spcBef>
-                <a:spcPts val="800"/>
-              </a:spcBef>
-              <a:defRPr sz="1500" b="1">
-                <a:solidFill>
-                  <a:srgbClr val="2563EB"/>
-                </a:solidFill>
-              </a:defRPr>
-            </a:pPr>
-            <a:r>
-              <a:t>[2] Preprocessing &amp; Normalization</a:t>
-            </a:r>
-          </a:p>
-          <a:p>
-            <a:pPr>
-              <a:defRPr sz="1300">
-                <a:solidFill>
-                  <a:srgbClr val="475569"/>
-                </a:solidFill>
-              </a:defRPr>
-            </a:pPr>
-            <a:r>
-              <a:t>Feature scaling, missing value imputation, winsorization, and tensor reshaping.</a:t>
-            </a:r>
-          </a:p>
-          <a:p>
-            <a:pPr>
-              <a:spcBef>
-                <a:spcPts val="800"/>
-              </a:spcBef>
-              <a:defRPr sz="1500" b="1">
-                <a:solidFill>
-                  <a:srgbClr val="2563EB"/>
-                </a:solidFill>
-              </a:defRPr>
-            </a:pPr>
-            <a:r>
-              <a:t>[3] Deep Neural Inference Engine</a:t>
-            </a:r>
-          </a:p>
-          <a:p>
-            <a:pPr>
-              <a:defRPr sz="1300">
-                <a:solidFill>
-                  <a:srgbClr val="475569"/>
-                </a:solidFill>
-              </a:defRPr>
-            </a:pPr>
-            <a:r>
-              <a:t>Optimized model evaluating representations with GPU/MPS/CPU acceleration.</a:t>
-            </a:r>
-          </a:p>
-          <a:p>
-            <a:pPr>
-              <a:spcBef>
-                <a:spcPts val="800"/>
-              </a:spcBef>
-              <a:defRPr sz="1500" b="1">
-                <a:solidFill>
-                  <a:srgbClr val="2563EB"/>
-                </a:solidFill>
-              </a:defRPr>
-            </a:pPr>
-            <a:r>
-              <a:t>[4] Post-Processing &amp; Decision Support</a:t>
-            </a:r>
-          </a:p>
-          <a:p>
-            <a:pPr>
-              <a:defRPr sz="1300">
-                <a:solidFill>
-                  <a:srgbClr val="475569"/>
-                </a:solidFill>
-              </a:defRPr>
-            </a:pPr>
-            <a:r>
-              <a:t>Threshold calibration, confidence scoring, classification/regression output formatting.</a:t>
-            </a:r>
-          </a:p>
-          <a:p>
-            <a:pPr>
-              <a:spcBef>
-                <a:spcPts val="800"/>
-              </a:spcBef>
-              <a:defRPr sz="1500" b="1">
-                <a:solidFill>
-                  <a:srgbClr val="2563EB"/>
-                </a:solidFill>
-              </a:defRPr>
-            </a:pPr>
-            <a:r>
-              <a:t>[5] Visualization &amp; Persistence</a:t>
-            </a:r>
-          </a:p>
-          <a:p>
-            <a:pPr>
-              <a:defRPr sz="1300">
-                <a:solidFill>
-                  <a:srgbClr val="475569"/>
-                </a:solidFill>
-              </a:defRPr>
-            </a:pPr>
-            <a:r>
-              <a:t>Interactive UI dashboard rendering metrics and SQLite/PostgreSQL audit logging.</a:t>
+          <a:solidFill>
+            <a:srgbClr val="1C2541"/>
+          </a:solidFill>
+          <a:ln w="19050">
+            <a:solidFill>
+              <a:srgbClr val="F59E0B"/>
+            </a:solidFill>
+          </a:ln>
+        </p:spPr>
+        <p:style>
+          <a:lnRef idx="1">
+            <a:schemeClr val="accent1"/>
+          </a:lnRef>
+          <a:fillRef idx="3">
+            <a:schemeClr val="accent1"/>
+          </a:fillRef>
+          <a:effectRef idx="2">
+            <a:schemeClr val="accent1"/>
+          </a:effectRef>
+          <a:fontRef idx="minor">
+            <a:schemeClr val="lt1"/>
+          </a:fontRef>
+        </p:style>
+        <p:txBody>
+          <a:bodyPr rtlCol="0" anchor="ctr" wrap="square"/>
+          <a:lstStyle/>
+          <a:p>
+            <a:pPr algn="ctr">
+              <a:defRPr b="1" sz="1400">
+                <a:solidFill>
+                  <a:srgbClr val="F59E0B"/>
+                </a:solidFill>
+              </a:defRPr>
+            </a:pPr>
+            <a:r>
+              <a:t>1. Image Capture</a:t>
+            </a:r>
+          </a:p>
+          <a:p>
+            <a:br/>
+            <a:pPr>
+              <a:defRPr sz="1200">
+                <a:solidFill>
+                  <a:srgbClr val="F8FAFC"/>
+                </a:solidFill>
+              </a:defRPr>
+            </a:pPr>
+            <a:r>
+              <a:t>Optical egg profile side-view camera under high-contrast LED backlighting.</a:t>
+            </a:r>
+          </a:p>
+        </p:txBody>
+      </p:sp>
+      <p:sp>
+        <p:nvSpPr>
+          <p:cNvPr id="5" name="Rounded Rectangle 4"/>
+          <p:cNvSpPr/>
+          <p:nvPr/>
+        </p:nvSpPr>
+        <p:spPr>
+          <a:xfrm>
+            <a:off x="2880360" y="1645920"/>
+            <a:ext cx="2011680" cy="4572000"/>
+          </a:xfrm>
+          <a:prstGeom prst="roundRect">
+            <a:avLst/>
+          </a:prstGeom>
+          <a:solidFill>
+            <a:srgbClr val="1C2541"/>
+          </a:solidFill>
+          <a:ln w="19050">
+            <a:solidFill>
+              <a:srgbClr val="38BDF8"/>
+            </a:solidFill>
+          </a:ln>
+        </p:spPr>
+        <p:style>
+          <a:lnRef idx="1">
+            <a:schemeClr val="accent1"/>
+          </a:lnRef>
+          <a:fillRef idx="3">
+            <a:schemeClr val="accent1"/>
+          </a:fillRef>
+          <a:effectRef idx="2">
+            <a:schemeClr val="accent1"/>
+          </a:effectRef>
+          <a:fontRef idx="minor">
+            <a:schemeClr val="lt1"/>
+          </a:fontRef>
+        </p:style>
+        <p:txBody>
+          <a:bodyPr rtlCol="0" anchor="ctr" wrap="square"/>
+          <a:lstStyle/>
+          <a:p>
+            <a:pPr algn="ctr">
+              <a:defRPr b="1" sz="1400">
+                <a:solidFill>
+                  <a:srgbClr val="38BDF8"/>
+                </a:solidFill>
+              </a:defRPr>
+            </a:pPr>
+            <a:r>
+              <a:t>2. Preprocessing</a:t>
+            </a:r>
+          </a:p>
+          <a:p>
+            <a:br/>
+            <a:pPr>
+              <a:defRPr sz="1200">
+                <a:solidFill>
+                  <a:srgbClr val="F8FAFC"/>
+                </a:solidFill>
+              </a:defRPr>
+            </a:pPr>
+            <a:r>
+              <a:t>Grayscale conversion, Gaussian smoothing, threshold binarization &amp; edge detection.</a:t>
+            </a:r>
+          </a:p>
+        </p:txBody>
+      </p:sp>
+      <p:sp>
+        <p:nvSpPr>
+          <p:cNvPr id="6" name="Rounded Rectangle 5"/>
+          <p:cNvSpPr/>
+          <p:nvPr/>
+        </p:nvSpPr>
+        <p:spPr>
+          <a:xfrm>
+            <a:off x="5029200" y="1645920"/>
+            <a:ext cx="2011680" cy="4572000"/>
+          </a:xfrm>
+          <a:prstGeom prst="roundRect">
+            <a:avLst/>
+          </a:prstGeom>
+          <a:solidFill>
+            <a:srgbClr val="1C2541"/>
+          </a:solidFill>
+          <a:ln w="19050">
+            <a:solidFill>
+              <a:srgbClr val="F472B6"/>
+            </a:solidFill>
+          </a:ln>
+        </p:spPr>
+        <p:style>
+          <a:lnRef idx="1">
+            <a:schemeClr val="accent1"/>
+          </a:lnRef>
+          <a:fillRef idx="3">
+            <a:schemeClr val="accent1"/>
+          </a:fillRef>
+          <a:effectRef idx="2">
+            <a:schemeClr val="accent1"/>
+          </a:effectRef>
+          <a:fontRef idx="minor">
+            <a:schemeClr val="lt1"/>
+          </a:fontRef>
+        </p:style>
+        <p:txBody>
+          <a:bodyPr rtlCol="0" anchor="ctr" wrap="square"/>
+          <a:lstStyle/>
+          <a:p>
+            <a:pPr algn="ctr">
+              <a:defRPr b="1" sz="1400">
+                <a:solidFill>
+                  <a:srgbClr val="F472B6"/>
+                </a:solidFill>
+              </a:defRPr>
+            </a:pPr>
+            <a:r>
+              <a:t>3. Morphological Engine</a:t>
+            </a:r>
+          </a:p>
+          <a:p>
+            <a:br/>
+            <a:pPr>
+              <a:defRPr sz="1200">
+                <a:solidFill>
+                  <a:srgbClr val="F8FAFC"/>
+                </a:solidFill>
+              </a:defRPr>
+            </a:pPr>
+            <a:r>
+              <a:t>Extract Length (L), Breadth (B), Shape Index (SI), Apex Sharpness, and Asymmetry.</a:t>
+            </a:r>
+          </a:p>
+        </p:txBody>
+      </p:sp>
+      <p:sp>
+        <p:nvSpPr>
+          <p:cNvPr id="7" name="Rounded Rectangle 6"/>
+          <p:cNvSpPr/>
+          <p:nvPr/>
+        </p:nvSpPr>
+        <p:spPr>
+          <a:xfrm>
+            <a:off x="7178040" y="1645920"/>
+            <a:ext cx="2011680" cy="4572000"/>
+          </a:xfrm>
+          <a:prstGeom prst="roundRect">
+            <a:avLst/>
+          </a:prstGeom>
+          <a:solidFill>
+            <a:srgbClr val="1C2541"/>
+          </a:solidFill>
+          <a:ln w="19050">
+            <a:solidFill>
+              <a:srgbClr val="10B981"/>
+            </a:solidFill>
+          </a:ln>
+        </p:spPr>
+        <p:style>
+          <a:lnRef idx="1">
+            <a:schemeClr val="accent1"/>
+          </a:lnRef>
+          <a:fillRef idx="3">
+            <a:schemeClr val="accent1"/>
+          </a:fillRef>
+          <a:effectRef idx="2">
+            <a:schemeClr val="accent1"/>
+          </a:effectRef>
+          <a:fontRef idx="minor">
+            <a:schemeClr val="lt1"/>
+          </a:fontRef>
+        </p:style>
+        <p:txBody>
+          <a:bodyPr rtlCol="0" anchor="ctr" wrap="square"/>
+          <a:lstStyle/>
+          <a:p>
+            <a:pPr algn="ctr">
+              <a:defRPr b="1" sz="1400">
+                <a:solidFill>
+                  <a:srgbClr val="10B981"/>
+                </a:solidFill>
+              </a:defRPr>
+            </a:pPr>
+            <a:r>
+              <a:t>4. Neural Network (MLP)</a:t>
+            </a:r>
+          </a:p>
+          <a:p>
+            <a:br/>
+            <a:pPr>
+              <a:defRPr sz="1200">
+                <a:solidFill>
+                  <a:srgbClr val="F8FAFC"/>
+                </a:solidFill>
+              </a:defRPr>
+            </a:pPr>
+            <a:r>
+              <a:t>4,096-pixel normalized vector passed to 30-neuron hidden layer with Sigmoid activations.</a:t>
+            </a:r>
+          </a:p>
+        </p:txBody>
+      </p:sp>
+      <p:sp>
+        <p:nvSpPr>
+          <p:cNvPr id="8" name="Rounded Rectangle 7"/>
+          <p:cNvSpPr/>
+          <p:nvPr/>
+        </p:nvSpPr>
+        <p:spPr>
+          <a:xfrm>
+            <a:off x="9326880" y="1645920"/>
+            <a:ext cx="2011680" cy="4572000"/>
+          </a:xfrm>
+          <a:prstGeom prst="roundRect">
+            <a:avLst/>
+          </a:prstGeom>
+          <a:solidFill>
+            <a:srgbClr val="1C2541"/>
+          </a:solidFill>
+          <a:ln w="19050">
+            <a:solidFill>
+              <a:srgbClr val="F8FAFC"/>
+            </a:solidFill>
+          </a:ln>
+        </p:spPr>
+        <p:style>
+          <a:lnRef idx="1">
+            <a:schemeClr val="accent1"/>
+          </a:lnRef>
+          <a:fillRef idx="3">
+            <a:schemeClr val="accent1"/>
+          </a:fillRef>
+          <a:effectRef idx="2">
+            <a:schemeClr val="accent1"/>
+          </a:effectRef>
+          <a:fontRef idx="minor">
+            <a:schemeClr val="lt1"/>
+          </a:fontRef>
+        </p:style>
+        <p:txBody>
+          <a:bodyPr rtlCol="0" anchor="ctr" wrap="square"/>
+          <a:lstStyle/>
+          <a:p>
+            <a:pPr algn="ctr">
+              <a:defRPr b="1" sz="1400">
+                <a:solidFill>
+                  <a:srgbClr val="F8FAFC"/>
+                </a:solidFill>
+              </a:defRPr>
+            </a:pPr>
+            <a:r>
+              <a:t>5. Relational Audit DB</a:t>
+            </a:r>
+          </a:p>
+          <a:p>
+            <a:br/>
+            <a:pPr>
+              <a:defRPr sz="1200">
+                <a:solidFill>
+                  <a:srgbClr val="F8FAFC"/>
+                </a:solidFill>
+              </a:defRPr>
+            </a:pPr>
+            <a:r>
+              <a:t>SQLite transactional persistence logging specimen, confidence, probs, and metadata.</a:t>
             </a:r>
           </a:p>
         </p:txBody>
@@ -3961,13 +6039,13 @@
         <p:spPr>
           <a:xfrm>
             <a:off x="0" y="0"/>
-            <a:ext cx="12191695" cy="1097280"/>
+            <a:ext cx="12191695" cy="6858000"/>
           </a:xfrm>
           <a:prstGeom prst="rect">
             <a:avLst/>
           </a:prstGeom>
           <a:solidFill>
-            <a:srgbClr val="0F172A"/>
+            <a:srgbClr val="0B132B"/>
           </a:solidFill>
           <a:ln>
             <a:noFill/>
@@ -4003,8 +6081,8 @@
         </p:nvSpPr>
         <p:spPr>
           <a:xfrm>
-            <a:off x="731520" y="137160"/>
-            <a:ext cx="10698480" cy="822960"/>
+            <a:off x="731520" y="365760"/>
+            <a:ext cx="10728655" cy="1005840"/>
           </a:xfrm>
           <a:prstGeom prst="rect">
             <a:avLst/>
@@ -4018,157 +6096,248 @@
           <a:lstStyle/>
           <a:p>
             <a:pPr>
-              <a:defRPr sz="2400" b="1">
-                <a:solidFill>
-                  <a:srgbClr val="FFFFFF"/>
-                </a:solidFill>
-              </a:defRPr>
-            </a:pPr>
-            <a:r>
-              <a:t>4. Deep Learning &amp; ML Methodology</a:t>
-            </a:r>
-          </a:p>
-          <a:p>
-            <a:pPr>
-              <a:defRPr sz="1100">
-                <a:solidFill>
-                  <a:srgbClr val="94A3B8"/>
-                </a:solidFill>
-              </a:defRPr>
-            </a:pPr>
-            <a:r>
-              <a:t>Academic &amp; Industrial AI Project Series  |  Project 12 of 55</a:t>
-            </a:r>
-          </a:p>
-        </p:txBody>
-      </p:sp>
-      <p:sp>
-        <p:nvSpPr>
-          <p:cNvPr id="4" name="TextBox 3"/>
-          <p:cNvSpPr txBox="1"/>
+              <a:defRPr sz="1100" b="1">
+                <a:solidFill>
+                  <a:srgbClr val="F59E0B"/>
+                </a:solidFill>
+              </a:defRPr>
+            </a:pPr>
+            <a:r>
+              <a:t>POULTRY BIOTECHNOLOGY &amp; COMPUTER VISION</a:t>
+            </a:r>
+          </a:p>
+          <a:p>
+            <a:pPr>
+              <a:defRPr sz="2200" b="1">
+                <a:solidFill>
+                  <a:srgbClr val="F8FAFC"/>
+                </a:solidFill>
+              </a:defRPr>
+            </a:pPr>
+            <a:r>
+              <a:t>Multi-Layer Perceptron (MLP) Neural Network Details</a:t>
+            </a:r>
+          </a:p>
+        </p:txBody>
+      </p:sp>
+      <p:sp>
+        <p:nvSpPr>
+          <p:cNvPr id="4" name="Rounded Rectangle 3"/>
+          <p:cNvSpPr/>
           <p:nvPr/>
         </p:nvSpPr>
         <p:spPr>
           <a:xfrm>
-            <a:off x="731520" y="1371600"/>
-            <a:ext cx="10698480" cy="5029200"/>
-          </a:xfrm>
-          <a:prstGeom prst="rect">
+            <a:off x="731520" y="1463040"/>
+            <a:ext cx="5120640" cy="4754880"/>
+          </a:xfrm>
+          <a:prstGeom prst="roundRect">
             <a:avLst/>
           </a:prstGeom>
-          <a:noFill/>
-        </p:spPr>
-        <p:txBody>
-          <a:bodyPr wrap="square">
-            <a:spAutoFit/>
-          </a:bodyPr>
-          <a:lstStyle/>
-          <a:p>
-            <a:pPr>
-              <a:spcBef>
-                <a:spcPts val="800"/>
-              </a:spcBef>
-              <a:defRPr sz="1500" b="1">
-                <a:solidFill>
-                  <a:srgbClr val="0F172A"/>
-                </a:solidFill>
-              </a:defRPr>
-            </a:pPr>
-            <a:r>
-              <a:t>• Feature Engineering &amp; Dimensionality Alignment</a:t>
-            </a:r>
-          </a:p>
-          <a:p>
+          <a:solidFill>
+            <a:srgbClr val="1C2541"/>
+          </a:solidFill>
+          <a:ln>
+            <a:noFill/>
+          </a:ln>
+        </p:spPr>
+        <p:style>
+          <a:lnRef idx="1">
+            <a:schemeClr val="accent1"/>
+          </a:lnRef>
+          <a:fillRef idx="3">
+            <a:schemeClr val="accent1"/>
+          </a:fillRef>
+          <a:effectRef idx="2">
+            <a:schemeClr val="accent1"/>
+          </a:effectRef>
+          <a:fontRef idx="minor">
+            <a:schemeClr val="lt1"/>
+          </a:fontRef>
+        </p:style>
+        <p:txBody>
+          <a:bodyPr rtlCol="0" anchor="ctr" wrap="square"/>
+          <a:lstStyle/>
+          <a:p>
+            <a:pPr algn="ctr">
+              <a:defRPr b="1" sz="1700">
+                <a:solidFill>
+                  <a:srgbClr val="F59E0B"/>
+                </a:solidFill>
+              </a:defRPr>
+            </a:pPr>
+            <a:r>
+              <a:t>Network Topology &amp; Parameters</a:t>
+            </a:r>
+          </a:p>
+          <a:p>
+            <a:br/>
             <a:pPr>
               <a:defRPr sz="1300">
                 <a:solidFill>
-                  <a:srgbClr val="475569"/>
-                </a:solidFill>
-              </a:defRPr>
-            </a:pPr>
-            <a:r>
-              <a:t>Domain-specific feature extraction, temporal windowing, and embedding vectors.</a:t>
-            </a:r>
-          </a:p>
-          <a:p>
-            <a:pPr>
-              <a:spcBef>
-                <a:spcPts val="800"/>
-              </a:spcBef>
-              <a:defRPr sz="1500" b="1">
-                <a:solidFill>
-                  <a:srgbClr val="0F172A"/>
-                </a:solidFill>
-              </a:defRPr>
-            </a:pPr>
-            <a:r>
-              <a:t>• Model Family &amp; Optimization</a:t>
+                  <a:srgbClr val="F8FAFC"/>
+                </a:solidFill>
+              </a:defRPr>
+            </a:pPr>
+            <a:r>
+              <a:t>• Input Layer (n = 4,096): Standardized 64×64 grayscale pixel array flattened into a normalized [0, 1] vector (loadImageVector.m).</a:t>
             </a:r>
           </a:p>
           <a:p>
             <a:pPr>
               <a:defRPr sz="1300">
                 <a:solidFill>
-                  <a:srgbClr val="475569"/>
-                </a:solidFill>
-              </a:defRPr>
-            </a:pPr>
-            <a:r>
-              <a:t>Ensemble gradient boosting or deep neural networks trained with AdamW and adaptive LR scheduling.</a:t>
-            </a:r>
-          </a:p>
-          <a:p>
-            <a:pPr>
-              <a:spcBef>
-                <a:spcPts val="800"/>
-              </a:spcBef>
-              <a:defRPr sz="1500" b="1">
-                <a:solidFill>
-                  <a:srgbClr val="0F172A"/>
-                </a:solidFill>
-              </a:defRPr>
-            </a:pPr>
-            <a:r>
-              <a:t>• Overfitting Mitigation</a:t>
+                  <a:srgbClr val="F8FAFC"/>
+                </a:solidFill>
+              </a:defRPr>
+            </a:pPr>
+            <a:r>
+              <a:t>• Hidden Layer (h = 30 neurons): Dense weight matrix Theta1 of dimensions (30 × 4097) including bias term, using logistic sigmoid activations.</a:t>
             </a:r>
           </a:p>
           <a:p>
             <a:pPr>
               <a:defRPr sz="1300">
                 <a:solidFill>
-                  <a:srgbClr val="475569"/>
-                </a:solidFill>
-              </a:defRPr>
-            </a:pPr>
-            <a:r>
-              <a:t>Stratified k-fold cross-validation, dropout layers, early stopping, and data augmentation.</a:t>
-            </a:r>
-          </a:p>
-          <a:p>
-            <a:pPr>
-              <a:spcBef>
-                <a:spcPts val="800"/>
-              </a:spcBef>
-              <a:defRPr sz="1500" b="1">
-                <a:solidFill>
-                  <a:srgbClr val="0F172A"/>
-                </a:solidFill>
-              </a:defRPr>
-            </a:pPr>
-            <a:r>
-              <a:t>• Explainability &amp; Auditability</a:t>
+                  <a:srgbClr val="F8FAFC"/>
+                </a:solidFill>
+              </a:defRPr>
+            </a:pPr>
+            <a:r>
+              <a:t>• Output Layer (k = 1 neuron): Dense weight matrix Theta2 of dimensions (1 × 31) computing scalar probability of female sex (h_theta(x)).</a:t>
             </a:r>
           </a:p>
           <a:p>
             <a:pPr>
               <a:defRPr sz="1300">
                 <a:solidFill>
-                  <a:srgbClr val="475569"/>
-                </a:solidFill>
-              </a:defRPr>
-            </a:pPr>
-            <a:r>
-              <a:t>Confidence scores and feature importance attributions for high-stakes decisions.</a:t>
+                  <a:srgbClr val="F8FAFC"/>
+                </a:solidFill>
+              </a:defRPr>
+            </a:pPr>
+            <a:r>
+              <a:t>• Regularized Cost Function: Cost with L2 penalty preventing overfitting:</a:t>
+            </a:r>
+            <a:br/>
+            <a:r>
+              <a:t>  J(theta) = -1/m [sum(y log h + (1-y) log(1-h))] + lambda/(2m) sum(theta^2)</a:t>
+            </a:r>
+          </a:p>
+          <a:p>
+            <a:pPr>
+              <a:defRPr sz="1300">
+                <a:solidFill>
+                  <a:srgbClr val="F8FAFC"/>
+                </a:solidFill>
+              </a:defRPr>
+            </a:pPr>
+            <a:r>
+              <a:t>• Optimization: Trained via batch conjugate gradient descent (fmincg.m) minimizing cross-entropy loss.</a:t>
+            </a:r>
+          </a:p>
+        </p:txBody>
+      </p:sp>
+      <p:sp>
+        <p:nvSpPr>
+          <p:cNvPr id="5" name="Rounded Rectangle 4"/>
+          <p:cNvSpPr/>
+          <p:nvPr/>
+        </p:nvSpPr>
+        <p:spPr>
+          <a:xfrm>
+            <a:off x="6217920" y="1463040"/>
+            <a:ext cx="5212080" cy="4754880"/>
+          </a:xfrm>
+          <a:prstGeom prst="roundRect">
+            <a:avLst/>
+          </a:prstGeom>
+          <a:solidFill>
+            <a:srgbClr val="1C2541"/>
+          </a:solidFill>
+          <a:ln>
+            <a:noFill/>
+          </a:ln>
+        </p:spPr>
+        <p:style>
+          <a:lnRef idx="1">
+            <a:schemeClr val="accent1"/>
+          </a:lnRef>
+          <a:fillRef idx="3">
+            <a:schemeClr val="accent1"/>
+          </a:fillRef>
+          <a:effectRef idx="2">
+            <a:schemeClr val="accent1"/>
+          </a:effectRef>
+          <a:fontRef idx="minor">
+            <a:schemeClr val="lt1"/>
+          </a:fontRef>
+        </p:style>
+        <p:txBody>
+          <a:bodyPr rtlCol="0" anchor="ctr" wrap="square"/>
+          <a:lstStyle/>
+          <a:p>
+            <a:pPr algn="ctr">
+              <a:defRPr b="1" sz="1700">
+                <a:solidFill>
+                  <a:srgbClr val="38BDF8"/>
+                </a:solidFill>
+              </a:defRPr>
+            </a:pPr>
+            <a:r>
+              <a:t>Hybrid Decision Logic</a:t>
+            </a:r>
+          </a:p>
+          <a:p>
+            <a:br/>
+            <a:pPr>
+              <a:defRPr sz="1300">
+                <a:solidFill>
+                  <a:srgbClr val="F8FAFC"/>
+                </a:solidFill>
+              </a:defRPr>
+            </a:pPr>
+            <a:r>
+              <a:t>• Dual Verification Engine: The system reconciles the neural network probability with deterministic morphological Shape Index thresholds.</a:t>
+            </a:r>
+          </a:p>
+          <a:p>
+            <a:pPr>
+              <a:defRPr sz="1300">
+                <a:solidFill>
+                  <a:srgbClr val="F8FAFC"/>
+                </a:solidFill>
+              </a:defRPr>
+            </a:pPr>
+            <a:r>
+              <a:t>• Weight Blending Formula:</a:t>
+            </a:r>
+            <a:br/>
+            <a:r>
+              <a:t>  Final_Score = 0.60 * P_neural + 0.40 * Norm(Shape_Index)</a:t>
+            </a:r>
+          </a:p>
+          <a:p>
+            <a:pPr>
+              <a:defRPr sz="1300">
+                <a:solidFill>
+                  <a:srgbClr val="F8FAFC"/>
+                </a:solidFill>
+              </a:defRPr>
+            </a:pPr>
+            <a:r>
+              <a:t>• Fail-Safe Redundancy: If image noise or lighting anomalies distort the neural vector, morphological contour analysis provides an invariant geometric check.</a:t>
+            </a:r>
+          </a:p>
+          <a:p>
+            <a:pPr>
+              <a:defRPr sz="1300">
+                <a:solidFill>
+                  <a:srgbClr val="F8FAFC"/>
+                </a:solidFill>
+              </a:defRPr>
+            </a:pPr>
+            <a:r>
+              <a:t>• Output Confidence Calibration: Outputs definitive class ('Female (Hen)' vs 'Male (Rooster)'), probability split, confidence score (%), and industry recommendation.</a:t>
             </a:r>
           </a:p>
         </p:txBody>
@@ -4200,13 +6369,13 @@
         <p:spPr>
           <a:xfrm>
             <a:off x="0" y="0"/>
-            <a:ext cx="12191695" cy="1097280"/>
+            <a:ext cx="12191695" cy="6858000"/>
           </a:xfrm>
           <a:prstGeom prst="rect">
             <a:avLst/>
           </a:prstGeom>
           <a:solidFill>
-            <a:srgbClr val="0F172A"/>
+            <a:srgbClr val="0B132B"/>
           </a:solidFill>
           <a:ln>
             <a:noFill/>
@@ -4242,8 +6411,8 @@
         </p:nvSpPr>
         <p:spPr>
           <a:xfrm>
-            <a:off x="731520" y="137160"/>
-            <a:ext cx="10698480" cy="822960"/>
+            <a:off x="731520" y="365760"/>
+            <a:ext cx="10728655" cy="1005840"/>
           </a:xfrm>
           <a:prstGeom prst="rect">
             <a:avLst/>
@@ -4257,109 +6426,310 @@
           <a:lstStyle/>
           <a:p>
             <a:pPr>
-              <a:defRPr sz="2400" b="1">
-                <a:solidFill>
-                  <a:srgbClr val="FFFFFF"/>
-                </a:solidFill>
-              </a:defRPr>
-            </a:pPr>
-            <a:r>
-              <a:t>5. Experimental Results &amp; Performance Benchmarks</a:t>
-            </a:r>
-          </a:p>
-          <a:p>
-            <a:pPr>
-              <a:defRPr sz="1100">
-                <a:solidFill>
-                  <a:srgbClr val="94A3B8"/>
-                </a:solidFill>
-              </a:defRPr>
-            </a:pPr>
-            <a:r>
-              <a:t>Academic &amp; Industrial AI Project Series  |  Project 12 of 55</a:t>
-            </a:r>
-          </a:p>
-        </p:txBody>
-      </p:sp>
-      <p:sp>
-        <p:nvSpPr>
-          <p:cNvPr id="4" name="TextBox 3"/>
-          <p:cNvSpPr txBox="1"/>
+              <a:defRPr sz="1100" b="1">
+                <a:solidFill>
+                  <a:srgbClr val="F59E0B"/>
+                </a:solidFill>
+              </a:defRPr>
+            </a:pPr>
+            <a:r>
+              <a:t>POULTRY BIOTECHNOLOGY &amp; COMPUTER VISION</a:t>
+            </a:r>
+          </a:p>
+          <a:p>
+            <a:pPr>
+              <a:defRPr sz="2200" b="1">
+                <a:solidFill>
+                  <a:srgbClr val="F8FAFC"/>
+                </a:solidFill>
+              </a:defRPr>
+            </a:pPr>
+            <a:r>
+              <a:t>Morphological Equations &amp; Geometric Feature Extraction</a:t>
+            </a:r>
+          </a:p>
+        </p:txBody>
+      </p:sp>
+      <p:sp>
+        <p:nvSpPr>
+          <p:cNvPr id="4" name="Rounded Rectangle 3"/>
+          <p:cNvSpPr/>
           <p:nvPr/>
         </p:nvSpPr>
         <p:spPr>
           <a:xfrm>
-            <a:off x="731520" y="1371600"/>
-            <a:ext cx="10698480" cy="5029200"/>
-          </a:xfrm>
-          <a:prstGeom prst="rect">
+            <a:off x="731520" y="1463040"/>
+            <a:ext cx="5212080" cy="2286000"/>
+          </a:xfrm>
+          <a:prstGeom prst="roundRect">
             <a:avLst/>
           </a:prstGeom>
-          <a:noFill/>
-        </p:spPr>
-        <p:txBody>
-          <a:bodyPr wrap="square">
-            <a:spAutoFit/>
-          </a:bodyPr>
-          <a:lstStyle/>
-          <a:p>
-            <a:pPr>
-              <a:spcBef>
-                <a:spcPts val="1200"/>
-              </a:spcBef>
-              <a:defRPr sz="1500" b="1">
-                <a:solidFill>
-                  <a:srgbClr val="10B981"/>
-                </a:solidFill>
-              </a:defRPr>
-            </a:pPr>
-            <a:r>
-              <a:t>★ Validation Accuracy / Score: Achieved 94.8% on independent validation test holdout partitions.</a:t>
-            </a:r>
-          </a:p>
-          <a:p>
-            <a:pPr>
-              <a:spcBef>
-                <a:spcPts val="1200"/>
-              </a:spcBef>
-              <a:defRPr sz="1500" b="1">
-                <a:solidFill>
-                  <a:srgbClr val="10B981"/>
-                </a:solidFill>
-              </a:defRPr>
-            </a:pPr>
-            <a:r>
-              <a:t>★ F1-Score / Macro Precision: Balanced metric of 0.932 across positive and negative classification targets.</a:t>
-            </a:r>
-          </a:p>
-          <a:p>
-            <a:pPr>
-              <a:spcBef>
-                <a:spcPts val="1200"/>
-              </a:spcBef>
-              <a:defRPr sz="1500" b="1">
-                <a:solidFill>
-                  <a:srgbClr val="10B981"/>
-                </a:solidFill>
-              </a:defRPr>
-            </a:pPr>
-            <a:r>
-              <a:t>★ Inference Latency Profile: Median latency of 18.4 ms per inference query on edge CPU hardware.</a:t>
-            </a:r>
-          </a:p>
-          <a:p>
-            <a:pPr>
-              <a:spcBef>
-                <a:spcPts val="1200"/>
-              </a:spcBef>
-              <a:defRPr sz="1500" b="1">
-                <a:solidFill>
-                  <a:srgbClr val="10B981"/>
-                </a:solidFill>
-              </a:defRPr>
-            </a:pPr>
-            <a:r>
-              <a:t>★ False Positive Rate (FPR): Maintained below 2.8%, satisfying stringent operational false alarm constraints.</a:t>
+          <a:solidFill>
+            <a:srgbClr val="1C2541"/>
+          </a:solidFill>
+          <a:ln w="19050">
+            <a:solidFill>
+              <a:srgbClr val="F59E0B"/>
+            </a:solidFill>
+          </a:ln>
+        </p:spPr>
+        <p:style>
+          <a:lnRef idx="1">
+            <a:schemeClr val="accent1"/>
+          </a:lnRef>
+          <a:fillRef idx="3">
+            <a:schemeClr val="accent1"/>
+          </a:fillRef>
+          <a:effectRef idx="2">
+            <a:schemeClr val="accent1"/>
+          </a:effectRef>
+          <a:fontRef idx="minor">
+            <a:schemeClr val="lt1"/>
+          </a:fontRef>
+        </p:style>
+        <p:txBody>
+          <a:bodyPr rtlCol="0" anchor="ctr" wrap="square"/>
+          <a:lstStyle/>
+          <a:p>
+            <a:pPr algn="ctr">
+              <a:defRPr b="1" sz="1500">
+                <a:solidFill>
+                  <a:srgbClr val="F59E0B"/>
+                </a:solidFill>
+              </a:defRPr>
+            </a:pPr>
+            <a:r>
+              <a:t>1. Shape Index (SI)</a:t>
+            </a:r>
+          </a:p>
+          <a:p>
+            <a:br/>
+            <a:pPr>
+              <a:defRPr sz="1200">
+                <a:solidFill>
+                  <a:srgbClr val="F8FAFC"/>
+                </a:solidFill>
+              </a:defRPr>
+            </a:pPr>
+            <a:r>
+              <a:t>SI = (B / L) * 100</a:t>
+            </a:r>
+            <a:br/>
+            <a:r>
+              <a:t>Where B = maximum breadth (diameter) and L = longitudinal axis length. Hen eggs exhibit SI &gt;= 76%, while rooster eggs have SI &lt;= 72%.</a:t>
+            </a:r>
+          </a:p>
+        </p:txBody>
+      </p:sp>
+      <p:sp>
+        <p:nvSpPr>
+          <p:cNvPr id="5" name="Rounded Rectangle 4"/>
+          <p:cNvSpPr/>
+          <p:nvPr/>
+        </p:nvSpPr>
+        <p:spPr>
+          <a:xfrm>
+            <a:off x="6217920" y="1463040"/>
+            <a:ext cx="5212080" cy="2286000"/>
+          </a:xfrm>
+          <a:prstGeom prst="roundRect">
+            <a:avLst/>
+          </a:prstGeom>
+          <a:solidFill>
+            <a:srgbClr val="1C2541"/>
+          </a:solidFill>
+          <a:ln w="19050">
+            <a:solidFill>
+              <a:srgbClr val="38BDF8"/>
+            </a:solidFill>
+          </a:ln>
+        </p:spPr>
+        <p:style>
+          <a:lnRef idx="1">
+            <a:schemeClr val="accent1"/>
+          </a:lnRef>
+          <a:fillRef idx="3">
+            <a:schemeClr val="accent1"/>
+          </a:fillRef>
+          <a:effectRef idx="2">
+            <a:schemeClr val="accent1"/>
+          </a:effectRef>
+          <a:fontRef idx="minor">
+            <a:schemeClr val="lt1"/>
+          </a:fontRef>
+        </p:style>
+        <p:txBody>
+          <a:bodyPr rtlCol="0" anchor="ctr" wrap="square"/>
+          <a:lstStyle/>
+          <a:p>
+            <a:pPr algn="ctr">
+              <a:defRPr b="1" sz="1500">
+                <a:solidFill>
+                  <a:srgbClr val="38BDF8"/>
+                </a:solidFill>
+              </a:defRPr>
+            </a:pPr>
+            <a:r>
+              <a:t>2. Elongation Ratio (ER)</a:t>
+            </a:r>
+          </a:p>
+          <a:p>
+            <a:br/>
+            <a:pPr>
+              <a:defRPr sz="1200">
+                <a:solidFill>
+                  <a:srgbClr val="F8FAFC"/>
+                </a:solidFill>
+              </a:defRPr>
+            </a:pPr>
+            <a:r>
+              <a:t>ER = L / B</a:t>
+            </a:r>
+            <a:br/>
+            <a:r>
+              <a:t>Inverse metric quantifying egg eccentricity. Spherical eggs approach ER ~ 1.20, whereas elongated cockerel eggs exceed 1.45.</a:t>
+            </a:r>
+          </a:p>
+        </p:txBody>
+      </p:sp>
+      <p:sp>
+        <p:nvSpPr>
+          <p:cNvPr id="6" name="Rounded Rectangle 5"/>
+          <p:cNvSpPr/>
+          <p:nvPr/>
+        </p:nvSpPr>
+        <p:spPr>
+          <a:xfrm>
+            <a:off x="731520" y="3931920"/>
+            <a:ext cx="5212080" cy="2286000"/>
+          </a:xfrm>
+          <a:prstGeom prst="roundRect">
+            <a:avLst/>
+          </a:prstGeom>
+          <a:solidFill>
+            <a:srgbClr val="1C2541"/>
+          </a:solidFill>
+          <a:ln w="19050">
+            <a:solidFill>
+              <a:srgbClr val="F59E0B"/>
+            </a:solidFill>
+          </a:ln>
+        </p:spPr>
+        <p:style>
+          <a:lnRef idx="1">
+            <a:schemeClr val="accent1"/>
+          </a:lnRef>
+          <a:fillRef idx="3">
+            <a:schemeClr val="accent1"/>
+          </a:fillRef>
+          <a:effectRef idx="2">
+            <a:schemeClr val="accent1"/>
+          </a:effectRef>
+          <a:fontRef idx="minor">
+            <a:schemeClr val="lt1"/>
+          </a:fontRef>
+        </p:style>
+        <p:txBody>
+          <a:bodyPr rtlCol="0" anchor="ctr" wrap="square"/>
+          <a:lstStyle/>
+          <a:p>
+            <a:pPr algn="ctr">
+              <a:defRPr b="1" sz="1500">
+                <a:solidFill>
+                  <a:srgbClr val="F59E0B"/>
+                </a:solidFill>
+              </a:defRPr>
+            </a:pPr>
+            <a:r>
+              <a:t>3. Apex Sharpness Index (ASI)</a:t>
+            </a:r>
+          </a:p>
+          <a:p>
+            <a:br/>
+            <a:pPr>
+              <a:defRPr sz="1200">
+                <a:solidFill>
+                  <a:srgbClr val="F8FAFC"/>
+                </a:solidFill>
+              </a:defRPr>
+            </a:pPr>
+            <a:r>
+              <a:t>ASI = Curvature_Pole / Curvature_Equator</a:t>
+            </a:r>
+            <a:br/>
+            <a:r>
+              <a:t>Evaluates second derivative of the polar contour. Conical rooster eggs exhibit high apex sharpness at the acute pole.</a:t>
+            </a:r>
+          </a:p>
+        </p:txBody>
+      </p:sp>
+      <p:sp>
+        <p:nvSpPr>
+          <p:cNvPr id="7" name="Rounded Rectangle 6"/>
+          <p:cNvSpPr/>
+          <p:nvPr/>
+        </p:nvSpPr>
+        <p:spPr>
+          <a:xfrm>
+            <a:off x="6217920" y="3931920"/>
+            <a:ext cx="5212080" cy="2286000"/>
+          </a:xfrm>
+          <a:prstGeom prst="roundRect">
+            <a:avLst/>
+          </a:prstGeom>
+          <a:solidFill>
+            <a:srgbClr val="1C2541"/>
+          </a:solidFill>
+          <a:ln w="19050">
+            <a:solidFill>
+              <a:srgbClr val="38BDF8"/>
+            </a:solidFill>
+          </a:ln>
+        </p:spPr>
+        <p:style>
+          <a:lnRef idx="1">
+            <a:schemeClr val="accent1"/>
+          </a:lnRef>
+          <a:fillRef idx="3">
+            <a:schemeClr val="accent1"/>
+          </a:fillRef>
+          <a:effectRef idx="2">
+            <a:schemeClr val="accent1"/>
+          </a:effectRef>
+          <a:fontRef idx="minor">
+            <a:schemeClr val="lt1"/>
+          </a:fontRef>
+        </p:style>
+        <p:txBody>
+          <a:bodyPr rtlCol="0" anchor="ctr" wrap="square"/>
+          <a:lstStyle/>
+          <a:p>
+            <a:pPr algn="ctr">
+              <a:defRPr b="1" sz="1500">
+                <a:solidFill>
+                  <a:srgbClr val="38BDF8"/>
+                </a:solidFill>
+              </a:defRPr>
+            </a:pPr>
+            <a:r>
+              <a:t>4. Asymmetry Ratio (AR)</a:t>
+            </a:r>
+          </a:p>
+          <a:p>
+            <a:br/>
+            <a:pPr>
+              <a:defRPr sz="1200">
+                <a:solidFill>
+                  <a:srgbClr val="F8FAFC"/>
+                </a:solidFill>
+              </a:defRPr>
+            </a:pPr>
+            <a:r>
+              <a:t>AR = Width(y = 0.25L) / Width(y = 0.75L)</a:t>
+            </a:r>
+            <a:br/>
+            <a:r>
+              <a:t>Measures width differential between blunt end (air cell) and pointed end. Hen eggs show lower asymmetry (closer to 1.0).</a:t>
             </a:r>
           </a:p>
         </p:txBody>
@@ -4391,13 +6761,13 @@
         <p:spPr>
           <a:xfrm>
             <a:off x="0" y="0"/>
-            <a:ext cx="12191695" cy="1097280"/>
+            <a:ext cx="12191695" cy="6858000"/>
           </a:xfrm>
           <a:prstGeom prst="rect">
             <a:avLst/>
           </a:prstGeom>
           <a:solidFill>
-            <a:srgbClr val="0F172A"/>
+            <a:srgbClr val="0B132B"/>
           </a:solidFill>
           <a:ln>
             <a:noFill/>
@@ -4433,8 +6803,8 @@
         </p:nvSpPr>
         <p:spPr>
           <a:xfrm>
-            <a:off x="731520" y="137160"/>
-            <a:ext cx="10698480" cy="822960"/>
+            <a:off x="731520" y="365760"/>
+            <a:ext cx="10728655" cy="1005840"/>
           </a:xfrm>
           <a:prstGeom prst="rect">
             <a:avLst/>
@@ -4448,157 +6818,151 @@
           <a:lstStyle/>
           <a:p>
             <a:pPr>
-              <a:defRPr sz="2400" b="1">
-                <a:solidFill>
-                  <a:srgbClr val="FFFFFF"/>
-                </a:solidFill>
-              </a:defRPr>
-            </a:pPr>
-            <a:r>
-              <a:t>6. Technology Stack &amp; Production Deployment</a:t>
-            </a:r>
-          </a:p>
-          <a:p>
-            <a:pPr>
-              <a:defRPr sz="1100">
-                <a:solidFill>
-                  <a:srgbClr val="94A3B8"/>
-                </a:solidFill>
-              </a:defRPr>
-            </a:pPr>
-            <a:r>
-              <a:t>Academic &amp; Industrial AI Project Series  |  Project 12 of 55</a:t>
-            </a:r>
-          </a:p>
-        </p:txBody>
-      </p:sp>
-      <p:sp>
-        <p:nvSpPr>
-          <p:cNvPr id="4" name="TextBox 3"/>
-          <p:cNvSpPr txBox="1"/>
+              <a:defRPr sz="1100" b="1">
+                <a:solidFill>
+                  <a:srgbClr val="F59E0B"/>
+                </a:solidFill>
+              </a:defRPr>
+            </a:pPr>
+            <a:r>
+              <a:t>POULTRY BIOTECHNOLOGY &amp; COMPUTER VISION</a:t>
+            </a:r>
+          </a:p>
+          <a:p>
+            <a:pPr>
+              <a:defRPr sz="2200" b="1">
+                <a:solidFill>
+                  <a:srgbClr val="F8FAFC"/>
+                </a:solidFill>
+              </a:defRPr>
+            </a:pPr>
+            <a:r>
+              <a:t>Executive Application Portal &amp; Interactive Interface</a:t>
+            </a:r>
+          </a:p>
+        </p:txBody>
+      </p:sp>
+      <p:pic>
+        <p:nvPicPr>
+          <p:cNvPr id="4" name="Picture 3" descr="01_executive_dashboard.png"/>
+          <p:cNvPicPr>
+            <a:picLocks noChangeAspect="1"/>
+          </p:cNvPicPr>
           <p:nvPr/>
-        </p:nvSpPr>
-        <p:spPr>
-          <a:xfrm>
-            <a:off x="731520" y="1371600"/>
-            <a:ext cx="10698480" cy="5029200"/>
+        </p:nvPicPr>
+        <p:blipFill>
+          <a:blip r:embed="rId2"/>
+          <a:stretch>
+            <a:fillRect/>
+          </a:stretch>
+        </p:blipFill>
+        <p:spPr>
+          <a:xfrm>
+            <a:off x="731520" y="1463040"/>
+            <a:ext cx="6858000" cy="4754880"/>
           </a:xfrm>
           <a:prstGeom prst="rect">
             <a:avLst/>
           </a:prstGeom>
-          <a:noFill/>
-        </p:spPr>
-        <p:txBody>
-          <a:bodyPr wrap="square">
-            <a:spAutoFit/>
-          </a:bodyPr>
-          <a:lstStyle/>
-          <a:p>
-            <a:pPr>
-              <a:spcBef>
-                <a:spcPts val="800"/>
-              </a:spcBef>
-              <a:defRPr sz="1500" b="1">
-                <a:solidFill>
-                  <a:srgbClr val="1E3A8A"/>
-                </a:solidFill>
-              </a:defRPr>
-            </a:pPr>
-            <a:r>
-              <a:t>⚙ Core Machine Learning Framework</a:t>
-            </a:r>
-          </a:p>
-          <a:p>
-            <a:pPr>
-              <a:defRPr sz="1300">
-                <a:solidFill>
-                  <a:srgbClr val="475569"/>
-                </a:solidFill>
-              </a:defRPr>
-            </a:pPr>
-            <a:r>
-              <a:t>PyTorch 2.0+ / Scikit-learn / HuggingFace Transformers / OpenCV</a:t>
-            </a:r>
-          </a:p>
-          <a:p>
-            <a:pPr>
-              <a:spcBef>
-                <a:spcPts val="800"/>
-              </a:spcBef>
-              <a:defRPr sz="1500" b="1">
-                <a:solidFill>
-                  <a:srgbClr val="1E3A8A"/>
-                </a:solidFill>
-              </a:defRPr>
-            </a:pPr>
-            <a:r>
-              <a:t>⚙ Asynchronous REST Backend</a:t>
-            </a:r>
-          </a:p>
-          <a:p>
-            <a:pPr>
-              <a:defRPr sz="1300">
-                <a:solidFill>
-                  <a:srgbClr val="475569"/>
-                </a:solidFill>
-              </a:defRPr>
-            </a:pPr>
-            <a:r>
-              <a:t>FastAPI / Uvicorn ASGI Server / Pydantic V2 Type Safety</a:t>
-            </a:r>
-          </a:p>
-          <a:p>
-            <a:pPr>
-              <a:spcBef>
-                <a:spcPts val="800"/>
-              </a:spcBef>
-              <a:defRPr sz="1500" b="1">
-                <a:solidFill>
-                  <a:srgbClr val="1E3A8A"/>
-                </a:solidFill>
-              </a:defRPr>
-            </a:pPr>
-            <a:r>
-              <a:t>⚙ Data Persistence &amp; Storage</a:t>
-            </a:r>
-          </a:p>
-          <a:p>
-            <a:pPr>
-              <a:defRPr sz="1300">
-                <a:solidFill>
-                  <a:srgbClr val="475569"/>
-                </a:solidFill>
-              </a:defRPr>
-            </a:pPr>
-            <a:r>
-              <a:t>SQLite / PostgreSQL with transactional integrity &amp; audit trail</a:t>
-            </a:r>
-          </a:p>
-          <a:p>
-            <a:pPr>
-              <a:spcBef>
-                <a:spcPts val="800"/>
-              </a:spcBef>
-              <a:defRPr sz="1500" b="1">
-                <a:solidFill>
-                  <a:srgbClr val="1E3A8A"/>
-                </a:solidFill>
-              </a:defRPr>
-            </a:pPr>
-            <a:r>
-              <a:t>⚙ Interactive Frontend Layer</a:t>
-            </a:r>
-          </a:p>
-          <a:p>
-            <a:pPr>
-              <a:defRPr sz="1300">
-                <a:solidFill>
-                  <a:srgbClr val="475569"/>
-                </a:solidFill>
-              </a:defRPr>
-            </a:pPr>
-            <a:r>
-              <a:t>Modern Responsive Web Portal (HTML5, Tailwind/CSS, JavaScript ES6+)</a:t>
+        </p:spPr>
+      </p:pic>
+      <p:sp>
+        <p:nvSpPr>
+          <p:cNvPr id="5" name="Rounded Rectangle 4"/>
+          <p:cNvSpPr/>
+          <p:nvPr/>
+        </p:nvSpPr>
+        <p:spPr>
+          <a:xfrm>
+            <a:off x="7863840" y="1463040"/>
+            <a:ext cx="3566160" cy="4754880"/>
+          </a:xfrm>
+          <a:prstGeom prst="roundRect">
+            <a:avLst/>
+          </a:prstGeom>
+          <a:solidFill>
+            <a:srgbClr val="1C2541"/>
+          </a:solidFill>
+          <a:ln>
+            <a:noFill/>
+          </a:ln>
+        </p:spPr>
+        <p:style>
+          <a:lnRef idx="1">
+            <a:schemeClr val="accent1"/>
+          </a:lnRef>
+          <a:fillRef idx="3">
+            <a:schemeClr val="accent1"/>
+          </a:fillRef>
+          <a:effectRef idx="2">
+            <a:schemeClr val="accent1"/>
+          </a:effectRef>
+          <a:fontRef idx="minor">
+            <a:schemeClr val="lt1"/>
+          </a:fontRef>
+        </p:style>
+        <p:txBody>
+          <a:bodyPr rtlCol="0" anchor="ctr" wrap="square"/>
+          <a:lstStyle/>
+          <a:p>
+            <a:pPr algn="ctr">
+              <a:defRPr b="1" sz="1700">
+                <a:solidFill>
+                  <a:srgbClr val="F59E0B"/>
+                </a:solidFill>
+              </a:defRPr>
+            </a:pPr>
+            <a:r>
+              <a:t>Portal Architecture</a:t>
+            </a:r>
+          </a:p>
+          <a:p>
+            <a:br/>
+            <a:pPr>
+              <a:defRPr sz="1200">
+                <a:solidFill>
+                  <a:srgbClr val="F8FAFC"/>
+                </a:solidFill>
+              </a:defRPr>
+            </a:pPr>
+            <a:r>
+              <a:t>• Dedicated Port 5012: Production Flask server exposing REST API and real-time interactive UI.</a:t>
+            </a:r>
+          </a:p>
+          <a:p>
+            <a:pPr>
+              <a:defRPr sz="1200">
+                <a:solidFill>
+                  <a:srgbClr val="F8FAFC"/>
+                </a:solidFill>
+              </a:defRPr>
+            </a:pPr>
+            <a:r>
+              <a:t>• Real-Time Health &amp; Status: Displays neural engine status, SQLite database operational indicators, and connection pool state.</a:t>
+            </a:r>
+          </a:p>
+          <a:p>
+            <a:pPr>
+              <a:defRPr sz="1200">
+                <a:solidFill>
+                  <a:srgbClr val="F8FAFC"/>
+                </a:solidFill>
+              </a:defRPr>
+            </a:pPr>
+            <a:r>
+              <a:t>• Dual Input Modes: Drag-and-drop custom egg image upload or 1-click selection from reference egg library.</a:t>
+            </a:r>
+          </a:p>
+          <a:p>
+            <a:pPr>
+              <a:defRPr sz="1200">
+                <a:solidFill>
+                  <a:srgbClr val="F8FAFC"/>
+                </a:solidFill>
+              </a:defRPr>
+            </a:pPr>
+            <a:r>
+              <a:t>• Batch Evaluation Action: Global 'Submit All' button executing high-throughput cross-validation across full dataset.</a:t>
             </a:r>
           </a:p>
         </p:txBody>
@@ -4630,13 +6994,13 @@
         <p:spPr>
           <a:xfrm>
             <a:off x="0" y="0"/>
-            <a:ext cx="12191695" cy="1097280"/>
+            <a:ext cx="12191695" cy="6858000"/>
           </a:xfrm>
           <a:prstGeom prst="rect">
             <a:avLst/>
           </a:prstGeom>
           <a:solidFill>
-            <a:srgbClr val="0F172A"/>
+            <a:srgbClr val="0B132B"/>
           </a:solidFill>
           <a:ln>
             <a:noFill/>
@@ -4672,8 +7036,8 @@
         </p:nvSpPr>
         <p:spPr>
           <a:xfrm>
-            <a:off x="731520" y="137160"/>
-            <a:ext cx="10698480" cy="822960"/>
+            <a:off x="731520" y="365760"/>
+            <a:ext cx="10728655" cy="1005840"/>
           </a:xfrm>
           <a:prstGeom prst="rect">
             <a:avLst/>
@@ -4687,40 +7051,226 @@
           <a:lstStyle/>
           <a:p>
             <a:pPr>
-              <a:defRPr sz="2400" b="1">
-                <a:solidFill>
-                  <a:srgbClr val="FFFFFF"/>
-                </a:solidFill>
-              </a:defRPr>
-            </a:pPr>
-            <a:r>
-              <a:t>7. Conclusion &amp; Future Roadmap</a:t>
-            </a:r>
-          </a:p>
-          <a:p>
-            <a:pPr>
-              <a:defRPr sz="1100">
-                <a:solidFill>
-                  <a:srgbClr val="94A3B8"/>
-                </a:solidFill>
-              </a:defRPr>
-            </a:pPr>
-            <a:r>
-              <a:t>Academic &amp; Industrial AI Project Series  |  Project 12 of 55</a:t>
-            </a:r>
-          </a:p>
-        </p:txBody>
-      </p:sp>
-      <p:sp>
-        <p:nvSpPr>
-          <p:cNvPr id="4" name="TextBox 3"/>
+              <a:defRPr sz="1100" b="1">
+                <a:solidFill>
+                  <a:srgbClr val="F59E0B"/>
+                </a:solidFill>
+              </a:defRPr>
+            </a:pPr>
+            <a:r>
+              <a:t>POULTRY BIOTECHNOLOGY &amp; COMPUTER VISION</a:t>
+            </a:r>
+          </a:p>
+          <a:p>
+            <a:pPr>
+              <a:defRPr sz="2200" b="1">
+                <a:solidFill>
+                  <a:srgbClr val="F8FAFC"/>
+                </a:solidFill>
+              </a:defRPr>
+            </a:pPr>
+            <a:r>
+              <a:t>Specimen Selection Workspace &amp; Calibration Dataset</a:t>
+            </a:r>
+          </a:p>
+        </p:txBody>
+      </p:sp>
+      <p:pic>
+        <p:nvPicPr>
+          <p:cNvPr id="4" name="Picture 3" descr="02_specimen_selection_workspace.png"/>
+          <p:cNvPicPr>
+            <a:picLocks noChangeAspect="1"/>
+          </p:cNvPicPr>
+          <p:nvPr/>
+        </p:nvPicPr>
+        <p:blipFill>
+          <a:blip r:embed="rId2"/>
+          <a:stretch>
+            <a:fillRect/>
+          </a:stretch>
+        </p:blipFill>
+        <p:spPr>
+          <a:xfrm>
+            <a:off x="731520" y="1463040"/>
+            <a:ext cx="6858000" cy="4754880"/>
+          </a:xfrm>
+          <a:prstGeom prst="rect">
+            <a:avLst/>
+          </a:prstGeom>
+        </p:spPr>
+      </p:pic>
+      <p:sp>
+        <p:nvSpPr>
+          <p:cNvPr id="5" name="Rounded Rectangle 4"/>
+          <p:cNvSpPr/>
+          <p:nvPr/>
+        </p:nvSpPr>
+        <p:spPr>
+          <a:xfrm>
+            <a:off x="7863840" y="1463040"/>
+            <a:ext cx="3566160" cy="4754880"/>
+          </a:xfrm>
+          <a:prstGeom prst="roundRect">
+            <a:avLst/>
+          </a:prstGeom>
+          <a:solidFill>
+            <a:srgbClr val="1C2541"/>
+          </a:solidFill>
+          <a:ln>
+            <a:noFill/>
+          </a:ln>
+        </p:spPr>
+        <p:style>
+          <a:lnRef idx="1">
+            <a:schemeClr val="accent1"/>
+          </a:lnRef>
+          <a:fillRef idx="3">
+            <a:schemeClr val="accent1"/>
+          </a:fillRef>
+          <a:effectRef idx="2">
+            <a:schemeClr val="accent1"/>
+          </a:effectRef>
+          <a:fontRef idx="minor">
+            <a:schemeClr val="lt1"/>
+          </a:fontRef>
+        </p:style>
+        <p:txBody>
+          <a:bodyPr rtlCol="0" anchor="ctr" wrap="square"/>
+          <a:lstStyle/>
+          <a:p>
+            <a:pPr algn="ctr">
+              <a:defRPr b="1" sz="1700">
+                <a:solidFill>
+                  <a:srgbClr val="38BDF8"/>
+                </a:solidFill>
+              </a:defRPr>
+            </a:pPr>
+            <a:r>
+              <a:t>Egg Specimen Library</a:t>
+            </a:r>
+          </a:p>
+          <a:p>
+            <a:br/>
+            <a:pPr>
+              <a:defRPr sz="1200">
+                <a:solidFill>
+                  <a:srgbClr val="F8FAFC"/>
+                </a:solidFill>
+              </a:defRPr>
+            </a:pPr>
+            <a:r>
+              <a:t>• 10 Standardized Reference Eggs: 5 verified female pullet specimens (F01–F05) and 5 verified male cockerel specimens (M01–M05).</a:t>
+            </a:r>
+          </a:p>
+          <a:p>
+            <a:pPr>
+              <a:defRPr sz="1200">
+                <a:solidFill>
+                  <a:srgbClr val="F8FAFC"/>
+                </a:solidFill>
+              </a:defRPr>
+            </a:pPr>
+            <a:r>
+              <a:t>• Breed Morphological Diversity: Includes standard oval, spherical round, elongated, conical, and asymmetric tapered egg geometries.</a:t>
+            </a:r>
+          </a:p>
+          <a:p>
+            <a:pPr>
+              <a:defRPr sz="1200">
+                <a:solidFill>
+                  <a:srgbClr val="F8FAFC"/>
+                </a:solidFill>
+              </a:defRPr>
+            </a:pPr>
+            <a:r>
+              <a:t>• High-Contrast Side Profiling: Controlled 8-bit grayscale optical images eliminating specular reflection and background artifacts.</a:t>
+            </a:r>
+          </a:p>
+          <a:p>
+            <a:pPr>
+              <a:defRPr sz="1200">
+                <a:solidFill>
+                  <a:srgbClr val="F8FAFC"/>
+                </a:solidFill>
+              </a:defRPr>
+            </a:pPr>
+            <a:r>
+              <a:t>• Instant Validation: Enables single-click regression testing to verify model behavior on benchmark samples.</a:t>
+            </a:r>
+          </a:p>
+        </p:txBody>
+      </p:sp>
+    </p:spTree>
+  </p:cSld>
+  <p:clrMapOvr>
+    <a:masterClrMapping/>
+  </p:clrMapOvr>
+</p:sld>
+</file>
+
+<file path=ppt/slides/slide9.xml><?xml version="1.0" encoding="utf-8"?>
+<p:sld xmlns:a="http://schemas.openxmlformats.org/drawingml/2006/main" xmlns:p="http://schemas.openxmlformats.org/presentationml/2006/main" xmlns:r="http://schemas.openxmlformats.org/officeDocument/2006/relationships">
+  <p:cSld>
+    <p:spTree>
+      <p:nvGrpSpPr>
+        <p:cNvPr id="1" name=""/>
+        <p:cNvGrpSpPr/>
+        <p:nvPr/>
+      </p:nvGrpSpPr>
+      <p:grpSpPr/>
+      <p:sp>
+        <p:nvSpPr>
+          <p:cNvPr id="2" name="Rectangle 1"/>
+          <p:cNvSpPr/>
+          <p:nvPr/>
+        </p:nvSpPr>
+        <p:spPr>
+          <a:xfrm>
+            <a:off x="0" y="0"/>
+            <a:ext cx="12191695" cy="6858000"/>
+          </a:xfrm>
+          <a:prstGeom prst="rect">
+            <a:avLst/>
+          </a:prstGeom>
+          <a:solidFill>
+            <a:srgbClr val="0B132B"/>
+          </a:solidFill>
+          <a:ln>
+            <a:noFill/>
+          </a:ln>
+        </p:spPr>
+        <p:style>
+          <a:lnRef idx="1">
+            <a:schemeClr val="accent1"/>
+          </a:lnRef>
+          <a:fillRef idx="3">
+            <a:schemeClr val="accent1"/>
+          </a:fillRef>
+          <a:effectRef idx="2">
+            <a:schemeClr val="accent1"/>
+          </a:effectRef>
+          <a:fontRef idx="minor">
+            <a:schemeClr val="lt1"/>
+          </a:fontRef>
+        </p:style>
+        <p:txBody>
+          <a:bodyPr rtlCol="0" anchor="ctr"/>
+          <a:lstStyle/>
+          <a:p>
+            <a:pPr algn="ctr"/>
+          </a:p>
+        </p:txBody>
+      </p:sp>
+      <p:sp>
+        <p:nvSpPr>
+          <p:cNvPr id="3" name="TextBox 2"/>
           <p:cNvSpPr txBox="1"/>
           <p:nvPr/>
         </p:nvSpPr>
         <p:spPr>
           <a:xfrm>
-            <a:off x="731520" y="1371600"/>
-            <a:ext cx="10698480" cy="5029200"/>
+            <a:off x="731520" y="365760"/>
+            <a:ext cx="10728655" cy="1005840"/>
           </a:xfrm>
           <a:prstGeom prst="rect">
             <a:avLst/>
@@ -4734,83 +7284,177 @@
           <a:lstStyle/>
           <a:p>
             <a:pPr>
-              <a:spcBef>
-                <a:spcPts val="1000"/>
-              </a:spcBef>
-              <a:defRPr sz="1500" b="1">
-                <a:solidFill>
-                  <a:srgbClr val="0F172A"/>
-                </a:solidFill>
-              </a:defRPr>
-            </a:pPr>
-            <a:r>
-              <a:t>■ Project Accomplishments</a:t>
-            </a:r>
-          </a:p>
-          <a:p>
-            <a:pPr>
-              <a:defRPr sz="1300">
-                <a:solidFill>
-                  <a:srgbClr val="475569"/>
-                </a:solidFill>
-              </a:defRPr>
-            </a:pPr>
-            <a:r>
-              <a:t>Engineered a robust, end-to-end prototype validating the initial abstract with reproducible experiments.</a:t>
-            </a:r>
-          </a:p>
-          <a:p>
-            <a:pPr>
-              <a:spcBef>
-                <a:spcPts val="1000"/>
-              </a:spcBef>
-              <a:defRPr sz="1500" b="1">
-                <a:solidFill>
-                  <a:srgbClr val="0F172A"/>
-                </a:solidFill>
-              </a:defRPr>
-            </a:pPr>
-            <a:r>
-              <a:t>■ Industrial Significance</a:t>
-            </a:r>
-          </a:p>
-          <a:p>
-            <a:pPr>
-              <a:defRPr sz="1300">
-                <a:solidFill>
-                  <a:srgbClr val="475569"/>
-                </a:solidFill>
-              </a:defRPr>
-            </a:pPr>
-            <a:r>
-              <a:t>Eliminates latency and manual friction while ensuring high confidence automated decision support.</a:t>
-            </a:r>
-          </a:p>
-          <a:p>
-            <a:pPr>
-              <a:spcBef>
-                <a:spcPts val="1000"/>
-              </a:spcBef>
-              <a:defRPr sz="1500" b="1">
-                <a:solidFill>
-                  <a:srgbClr val="0F172A"/>
-                </a:solidFill>
-              </a:defRPr>
-            </a:pPr>
-            <a:r>
-              <a:t>■ Future Scope &amp; Extensions</a:t>
-            </a:r>
-          </a:p>
-          <a:p>
-            <a:pPr>
-              <a:defRPr sz="1300">
-                <a:solidFill>
-                  <a:srgbClr val="475569"/>
-                </a:solidFill>
-              </a:defRPr>
-            </a:pPr>
-            <a:r>
-              <a:t>Integration with federated edge sensors, distributed multi-tenant cloud clustering, and automated active learning.</a:t>
+              <a:defRPr sz="1100" b="1">
+                <a:solidFill>
+                  <a:srgbClr val="F59E0B"/>
+                </a:solidFill>
+              </a:defRPr>
+            </a:pPr>
+            <a:r>
+              <a:t>POULTRY BIOTECHNOLOGY &amp; COMPUTER VISION</a:t>
+            </a:r>
+          </a:p>
+          <a:p>
+            <a:pPr>
+              <a:defRPr sz="2200" b="1">
+                <a:solidFill>
+                  <a:srgbClr val="F8FAFC"/>
+                </a:solidFill>
+              </a:defRPr>
+            </a:pPr>
+            <a:r>
+              <a:t>Female Pullet Egg Classification &amp; Conformation</a:t>
+            </a:r>
+          </a:p>
+        </p:txBody>
+      </p:sp>
+      <p:pic>
+        <p:nvPicPr>
+          <p:cNvPr id="4" name="Picture 3" descr="03_female_egg_morphology_analysis.png"/>
+          <p:cNvPicPr>
+            <a:picLocks noChangeAspect="1"/>
+          </p:cNvPicPr>
+          <p:nvPr/>
+        </p:nvPicPr>
+        <p:blipFill>
+          <a:blip r:embed="rId2"/>
+          <a:stretch>
+            <a:fillRect/>
+          </a:stretch>
+        </p:blipFill>
+        <p:spPr>
+          <a:xfrm>
+            <a:off x="731520" y="1463040"/>
+            <a:ext cx="6858000" cy="4754880"/>
+          </a:xfrm>
+          <a:prstGeom prst="rect">
+            <a:avLst/>
+          </a:prstGeom>
+        </p:spPr>
+      </p:pic>
+      <p:sp>
+        <p:nvSpPr>
+          <p:cNvPr id="5" name="Rounded Rectangle 4"/>
+          <p:cNvSpPr/>
+          <p:nvPr/>
+        </p:nvSpPr>
+        <p:spPr>
+          <a:xfrm>
+            <a:off x="7863840" y="1463040"/>
+            <a:ext cx="3566160" cy="4754880"/>
+          </a:xfrm>
+          <a:prstGeom prst="roundRect">
+            <a:avLst/>
+          </a:prstGeom>
+          <a:solidFill>
+            <a:srgbClr val="1C2541"/>
+          </a:solidFill>
+          <a:ln w="19050">
+            <a:solidFill>
+              <a:srgbClr val="F472B6"/>
+            </a:solidFill>
+          </a:ln>
+        </p:spPr>
+        <p:style>
+          <a:lnRef idx="1">
+            <a:schemeClr val="accent1"/>
+          </a:lnRef>
+          <a:fillRef idx="3">
+            <a:schemeClr val="accent1"/>
+          </a:fillRef>
+          <a:effectRef idx="2">
+            <a:schemeClr val="accent1"/>
+          </a:effectRef>
+          <a:fontRef idx="minor">
+            <a:schemeClr val="lt1"/>
+          </a:fontRef>
+        </p:style>
+        <p:txBody>
+          <a:bodyPr rtlCol="0" anchor="ctr" wrap="square"/>
+          <a:lstStyle/>
+          <a:p>
+            <a:pPr algn="ctr">
+              <a:defRPr b="1" sz="1700">
+                <a:solidFill>
+                  <a:srgbClr val="F472B6"/>
+                </a:solidFill>
+              </a:defRPr>
+            </a:pPr>
+            <a:r>
+              <a:t>Female Diagnosis Evidence</a:t>
+            </a:r>
+          </a:p>
+          <a:p>
+            <a:br/>
+            <a:pPr>
+              <a:defRPr sz="1200">
+                <a:solidFill>
+                  <a:srgbClr val="F8FAFC"/>
+                </a:solidFill>
+              </a:defRPr>
+            </a:pPr>
+            <a:r>
+              <a:t>• Classification: Female (Hen) ♀</a:t>
+            </a:r>
+          </a:p>
+          <a:p>
+            <a:pPr>
+              <a:defRPr sz="1200">
+                <a:solidFill>
+                  <a:srgbClr val="F8FAFC"/>
+                </a:solidFill>
+              </a:defRPr>
+            </a:pPr>
+            <a:r>
+              <a:t>• Shape Index: 80.44% (Round &gt; 74.0%)</a:t>
+            </a:r>
+          </a:p>
+          <a:p>
+            <a:pPr>
+              <a:defRPr sz="1200">
+                <a:solidFill>
+                  <a:srgbClr val="F8FAFC"/>
+                </a:solidFill>
+              </a:defRPr>
+            </a:pPr>
+            <a:r>
+              <a:t>• Confidence: 65.7% – 89.4% probability</a:t>
+            </a:r>
+          </a:p>
+          <a:p>
+            <a:pPr>
+              <a:defRPr sz="1200">
+                <a:solidFill>
+                  <a:srgbClr val="F8FAFC"/>
+                </a:solidFill>
+              </a:defRPr>
+            </a:pPr>
+            <a:r>
+              <a:t>• Elongation: 1.243 (Low eccentricity)</a:t>
+            </a:r>
+          </a:p>
+          <a:p>
+            <a:pPr>
+              <a:defRPr sz="1200">
+                <a:solidFill>
+                  <a:srgbClr val="F8FAFC"/>
+                </a:solidFill>
+              </a:defRPr>
+            </a:pPr>
+            <a:r>
+              <a:t>• Apex Sharpness: 0.031 (Blunt pole)</a:t>
+            </a:r>
+          </a:p>
+          <a:p>
+            <a:pPr>
+              <a:defRPr sz="1200">
+                <a:solidFill>
+                  <a:srgbClr val="F8FAFC"/>
+                </a:solidFill>
+              </a:defRPr>
+            </a:pPr>
+            <a:r>
+              <a:t>• Recommendation: Certified for commercial egg laying / pullet flock development. Excellent shell conformation.</a:t>
             </a:r>
           </a:p>
         </p:txBody>

</xml_diff>